<commit_message>
feat: mejora 2 guion
</commit_message>
<xml_diff>
--- a/defensa/OASIS_defensa_TFG.pptx
+++ b/defensa/OASIS_defensa_TFG.pptx
@@ -710,12 +710,12 @@
             <a:r>
               <a:rPr lang="en-US" dirty="0"/>
               <a:t>Antes de las cifras, las cuatro piezas que las sostienen.
-La primera es la comparación pareada, que es lo que ven en el esquema: la semilla ene genera el mismo perfil de demanda en todas las versiones, así que la diferencia se calcula par a par. El ruido de la demanda se cancela en la resta y el contraste gana potencia. Veinte pares: cuatro escenarios por cinco semillas.
-La segunda es el test de Wilcoxon, de rangos con signo. Empecé con un t-test y lo abandoné: tres semillas del escenario nublado dominaban la media, con medias hasta veinte veces la mediana. El contraste describía esas tres tiradas, no a la población.
-La tercera es un umbral de relevancia económica. Medí la dispersión del coste de la propia referencia entre grupos de semillas: nueve euros con treinta y tres por semana. Una diferencia significativa por debajo de eso la declaro operativamente nula, y lo fijé antes de simular.
-Y la cuarta es el oráculo: repetir una tanda con la previsión perfecta. No es desplegable, es una cota superior. Si con error cero una estrategia no gana, ninguna mejora de la previsión va a hacer que gane.
+La primera es comparar en pareja, que es el esquema: la misma semilla genera el mismo perfil de demanda para todas las versiones, así que comparo dos versiones sobre la misma semana y no dos promedios. El azar de la demanda se va en la resta. Veinte pares: cuatro escenarios por cinco semillas.
+La segunda es el test de Wilcoxon: en vez de mirar si la media mejora, mira si las diferencias caen siempre del mismo lado. Lo elegí porque unas pocas semanas nubladas muy caras bastaban para arrastrar la media.
+La tercera es un umbral de relevancia, y es el que me pongo en contra: por debajo de nueve euros a la semana, que es lo que varía la propia referencia solo por cambiar de semillas, lo doy por empate. Fijado antes de simular.
+Y la cuarta es el oráculo: repetir la tanda con la previsión perfecta. Es un techo. Si con previsión perfecta una idea no gana, mejorar la predicción no la va a salvar.
 — — — — —
-NO SE DICE · objetivo 1:27 · Ritmo pausado, una pieza cada vez. Es la diapositiva que te compra credibilidad para todo el bloque siguiente.</a:t>
+NO SE DICE · objetivo 1:19 · Ritmo pausado, una pieza cada vez. Es la diapositiva que te compra credibilidad para todo el bloque siguiente.</a:t>
             </a:r>
             <a:endParaRPr lang="en-US" dirty="0"/>
           </a:p>
@@ -895,12 +895,12 @@
           <a:p>
             <a:r>
               <a:rPr lang="en-US" dirty="0"/>
-              <a:t>La Versión B añade las dos previsiones donde la heurística ya decidía: la solar desplaza el reparto cuando anticipa que va a caer el excedente, y la de precio gobierna un arbitraje de batería.
-Y tiene una victoria clara: el servicio de hidrógeno. Mantiene el tanque de alta más lleno y pasa menos tiempo en nivel crítico, en treinta y nueve de cuarenta pares. Y escala con la calidad de la previsión: con oráculo se multiplica por diez. El mecanismo funciona; lo que limita es la previsión, no el diseño.
-En coste empata: trece céntimos sobre un recibo diario de unos cuarenta y cinco euros, y tampoco gana con previsión perfecta.
-De ahí sale la regla de diseño que aplico después: una primera implementación que traducía «el precio va a subir» en una acción de magnitud fija empeoraba el coste, y más cuanto mejor era la previsión. La acción tiene que estar condicionada y su magnitud salir del margen económico.
+              <a:t>La Versión B es la misma heurística con las dos previsiones metidas dentro. No cambia la arquitectura: cambia lo que mira la regla en el momento de decidir.
+La previsión solar entra en el reparto del excedente: antes dependía solo del estado de carga de ese instante; ahora, si la previsión anticipa que el excedente va a caer, el reparto se desplaza hacia la batería antes de que caiga. Y la de precio gobierna un arbitraje de batería.
+B tiene una victoria y un empate. La victoria es el servicio de hidrógeno, en treinta y nueve de cuarenta pares, y lo importante no es el tamaño sino que escala con la calidad de la previsión: con el oráculo se multiplica por diez. El mecanismo está bien planteado; lo que limita es la predicción.
+El empate es el coste, y de ahí sale la regla de diseño que aplico después: la primera versión del arbitraje traducía «el precio va a subir» en una acción de tamaño fijo, y empeoraba el coste, más cuanto mejor era la previsión. Una acción disparada por una previsión tiene que estar condicionada, y su tamaño salir del margen económico disponible.
 — — — — —
-NO SE DICE · objetivo 1:11 · Tono de quien informa. B tiene su victoria y la cuentas primero; el empate en coste viene después y sin disculpas.</a:t>
+NO SE DICE · objetivo 1:26 · Tono de quien informa. B tiene su victoria y la cuentas primero; el empate en coste viene después y sin disculpas.</a:t>
             </a:r>
             <a:endParaRPr lang="en-US" dirty="0"/>
           </a:p>
@@ -988,12 +988,12 @@
           <a:p>
             <a:r>
               <a:rPr lang="en-US" dirty="0"/>
-              <a:t>Al descomponer la importación de la Versión A por destinos aparece esto, y es lo que motiva el tercer gestor. Fíjense solo en la primera barra: las otras dos son la Versión C, que veremos enseguida.
-De los mil trescientos veintiún kilovatios-hora que la referencia compra a la red en una semana, mil seis —el setenta y seis por ciento— van al electrolizador, a ciento veintiuno con cinco euros el megavatio-hora. Los vehículos son el veintiuno por ciento.
-Y en los instantes exactos en que compra esa energía, la batería está al ochenta y cinco por ciento de carga de media, y nunca baja del sesenta y nueve.
-El motivo está en el orden del código: en la rama de déficit la batería cubre los vehículos y, en un paso posterior, la decisión económica enciende el electrolizador; esa carga nueva no se le vuelve a ofrecer a la batería, así que la absorbe la red. Toda la información necesaria ya estaba en las entradas.
+              <a:t>Al descomponer la importación de la Versión A por destinos aparece esto, y es lo que motiva el tercer gestor.
+De los mil trescientos veintiún kilovatios-hora que compra a la red en una semana, el setenta y seis por ciento van al electrolizador, a ciento veintiuno con cinco euros el megavatio-hora. Y en los instantes exactos en que los compra, la batería está al ochenta y cinco por ciento de media.
+Pongan eso junto al otro lado del balance: en esa misma semana la estación exporta catorce mil kilovatios-hora a treinta y nueve euros. Vende diez veces más energía de la que compra, y la compra tres veces más cara de lo que la vende. Está pasando la misma energía dos veces por el contador, y perdiendo en los dos sentidos.
+El motivo está en el orden del código: la batería cubre primero los vehículos y, en un paso posterior, la decisión económica enciende el electrolizador; esa carga nueva no se le vuelve a ofrecer, así que la absorbe la red.
 — — — — —
-NO SE DICE · objetivo 1:14 · Sobrio. Es un diagnóstico de ingeniería, no una revelación. Deja aire entre las tres cifras y sigue.</a:t>
+NO SE DICE · objetivo 1:17 · Sobrio. Es un diagnóstico de ingeniería, no una revelación. Deja aire entre las tres cifras y sigue.</a:t>
             </a:r>
             <a:endParaRPr lang="en-US" dirty="0"/>
           </a:p>
@@ -1081,12 +1081,13 @@
           <a:p>
             <a:r>
               <a:rPr lang="en-US" dirty="0"/>
-              <a:t>La Versión C separa dos decisiones que la heurística tomaba juntas: de dónde sale la energía del electrolizador y cuándo conviene producir. Cada cambio tiene su interruptor.
-El primero son diez líneas. En la rama de déficit, la carga que crea la decisión de producir hidrógeno se ofrece a la batería antes que a la red, mientras el estado de carga esté por encima de una reserva del sesenta por ciento. Ese sesenta sale del contrafactual: con ese piso, el setenta y nueve por ciento de esa importación podía haber salido de la batería. Y no consume ninguna previsión.
-El segundo es un planificador: se estima cuánto hidrógeno falta y cuánto excedente gratis va a haber, y se produce si la hora actual está entre las ene más baratas del horizonte.
-Lo que hace defendible esta regla es que solo usa el orden de los precios: contar cuántas horas futuras son más baratas es invariante a cualquier transformación monótona de la previsión.
+              <a:t>La Versión C separa dos decisiones que la heurística tomaba juntas: de dónde sale la energía del electrolizador y cuándo conviene producir. En pantalla, los cuatro pasos de la lógica común, con los dos que sustituyo en ámbar. Cada uno tiene su interruptor.
+El primero son diez líneas: la carga que crea la decisión de producir hidrógeno se le ofrece a la batería antes que a la red, mientras el estado de carga esté por encima del sesenta por ciento. Ese sesenta no es arbitrario, sale del contrafactual del diagnóstico anterior.
+El segundo es un planificador: estima cuánto hidrógeno falta y cuánto excedente gratis viene, y de ahí salen las horas de electrolizador que hay que comprar a la red, que se colocan en las más baratas del horizonte.
+Conviene precisar de dónde sale ese precio. El mercado diario publica sobre la una de la tarde las veinticuatro horas del día siguiente: la parte del horizonte que ya está publicada se usa tal cual, y solo se predice el tramo que aún no ha salido a mercado.
+Y lo que hace defendible la regla es que solo usa el orden: la decisión es «estoy entre las ene más baratas, sí o no». Eso no cambia si la previsión falla en el nivel mientras acierte en el orden. Sumarle diez euros a todas las horas da el mismo plan.
 — — — — —
-NO SE DICE · objetivo 1:12 · La invariancia monótona es el argumento más elegante del trabajo. Dilo despacio.</a:t>
+NO SE DICE · objetivo 1:42 · La invariancia monótona es el argumento más elegante del trabajo. Dilo despacio.</a:t>
             </a:r>
             <a:endParaRPr lang="en-US" dirty="0"/>
           </a:p>
@@ -1547,13 +1548,13 @@
           <a:p>
             <a:r>
               <a:rPr lang="en-US" dirty="0"/>
-              <a:t>El transporte es una cuarta parte de las emisiones de gases de efecto invernadero de la Unión, y casi tres cuartas partes de esa fracción son transporte por carretera. Es uno de los focos que el Pacto Verde Europeo tiene que cerrar para dos mil cincuenta.
-El marco regulatorio ya pone fechas. La Hoja de Ruta del Hidrógeno española fija entre cien y ciento cincuenta hidrogeneras públicas para dos mil treinta, y sitúa los corredores de repostaje verde como línea prioritaria. El PNIEC fija cinco millones y medio de vehículos eléctricos para esa misma fecha, y el reglamento europeo AFIR convierte el despliegue de recarga en objetivos vinculantes.
+              <a:t>El transporte es una cuarta parte de las emisiones de la Unión, y casi tres cuartas partes de esa fracción son carretera. Es uno de los focos que el Pacto Verde Europeo tiene que cerrar.
+El marco ya pone fechas. La Hoja de Ruta del Hidrógeno española fija entre cien y ciento cincuenta hidrogeneras públicas para dos mil treinta y sitúa los corredores de repostaje verde como prioridad; el PNIEC fija cinco millones y medio de vehículos eléctricos para esa fecha; y el reglamento europeo AFIR convierte el despliegue de recarga en objetivos vinculantes.
 El problema es esa fragmentación: cada vector arrastra hoy su propia infraestructura y su propia inversión.
-Y ya hay precedentes de integrarlas. Repsol inauguró en enero de dos mil veinticinco la estación de Morro Jable, en Fuerteventura: fotovoltaica, baterías, pila de hidrógeno y recarga eléctrica. Es prácticamente la combinación de componentes de OASIS, a menor escala y sin electrolizador propio.
+Y ya hay precedentes de integrarlas. Repsol inauguró en dos mil veinticinco la estación de Morro Jable, en Fuerteventura: fotovoltaica, baterías, pila de hidrógeno y recarga eléctrica. Es casi la combinación de OASIS, a menor escala y sin electrolizador propio.
 Con esa integración el reto deja de ser de dimensionamiento y pasa a ser de operación: decidir, en cada instante, de dónde sale cada kilovatio.
 — — — — —
-NO SE DICE · objetivo 1:26 · Las dos referencias que demuestran que has investigado —H2ME y Morro Jable— van habladas, no en pantalla. Morro Jable es tu mejor baza: casi los mismos componentes que OASIS.</a:t>
+NO SE DICE · objetivo 1:18 · Las dos referencias que demuestran que has investigado —H2ME y Morro Jable— van habladas, no en pantalla. Morro Jable es tu mejor baza: casi los mismos componentes que OASIS.</a:t>
             </a:r>
             <a:endParaRPr lang="en-US" dirty="0"/>
           </a:p>
@@ -2267,12 +2268,12 @@
             <a:r>
               <a:rPr lang="en-US" dirty="0"/>
               <a:t>El primer bloque de datos sirve para dimensionar, y fija dos parámetros de la instalación.
-La fuente es DESL-EPFL, sesiones reales de carga rápida: casi mil novecientas válidas, con una energía media de treinta y dos kilovatios-hora. La contrasto con Caltech, que es carga lenta, para comprobar que son familias distintas.
+La fuente es DESL-EPFL, casi mil novecientas sesiones reales de carga rápida, con una energía media de treinta y dos kilovatios-hora. La contrasto con Caltech, que es carga lenta, para comprobar que son familias distintas.
 De ahí salen las dos decisiones. Los cincuenta kilovatios del cargador, que es el estándar europeo de carga rápida en continua y que con la energía media cubren una sesión en unos cuarenta minutos, sin exigir transformador de media tensión. Y que los cargadores sean dos, por teoría de colas sobre la hora punta: con dos, la espera se mantiene acotada.
 Dimensiono sobre el panorama actual a propósito: es el escenario del que hay datos reales, y escalar hacia arriba siempre es más fácil que hacia abajo, más aún con una arquitectura modular como esta.
-Con esas mismas distribuciones se genera el perfil de demanda de cada simulación. Es estocástico, y eso importará en la comparación.
+Con esas distribuciones se genera el perfil de demanda de cada simulación. Es estocástico, y eso importará en la comparación.
 — — — — —
-NO SE DICE · objetivo 1:15 · Este bloque es trabajo tuyo de principio a fin. Cuéntalo con calma: es lo que justifica que la instalación sea creíble.</a:t>
+NO SE DICE · objetivo 1:14 · Este bloque es trabajo tuyo de principio a fin. Cuéntalo con calma: es lo que justifica que la instalación sea creíble.</a:t>
             </a:r>
             <a:endParaRPr lang="en-US" dirty="0"/>
           </a:p>
@@ -2453,11 +2454,11 @@
           <a:p>
             <a:r>
               <a:rPr lang="en-US" dirty="0"/>
-              <a:t>Las dos redes comparten arquitectura: dos capas LSTM apiladas, de ciento veintiocho y sesenta y cuatro unidades, con dropout, capa densa y salida de veinticuatro valores, que es el horizonte de un día.
-Las dos se entrenan con Adam y paran por criterio de validación: la solar en la época veintiuno de trescientas, la de precio en la veintinueve de doscientas. En pantalla, la curva de RMSE: azul entrenamiento, negro validación. No se separan: no hay sobreajuste.
-Una diferencia que sí importa: el modelo solar puede imponer que la irradiancia predicha no sea negativa. El de precio no, porque el precio spot admite negativos, y eso obliga después a un tratamiento distinto.
+              <a:t>Las dos redes comparten arquitectura: dos capas LSTM apiladas, de ciento veintiocho y sesenta y cuatro unidades, con dropout, capa densa y salida de veinticuatro valores, el horizonte de un día. Se entrenan con Adam y paran por criterio de validación. En pantalla, la curva de RMSE: azul entrenamiento, negro validación. No se separan: no hay sobreajuste.
+Entreno con RMSE, el error cuadrático medio, porque al elevar al cuadrado penaliza mucho más un fallo grande que varios pequeños, y aquí lo que rompe una decisión es el fallo grande: no ver una punta de precio o una caída de sol. Para comparar modelos uso después el error absoluto medio, que está en las unidades de la variable y no lo dominan cuatro horas atípicas.
+Una diferencia que importa: el modelo solar puede imponer que la irradiancia predicha no sea negativa. El de precio no, porque el precio admite negativos.
 — — — — —
-NO SE DICE · objetivo 0:50 · Rápida. Es la diapositiva de «así están hechas», no de resultados.</a:t>
+NO SE DICE · objetivo 1:06 · Rápida. Es la diapositiva de «así están hechas», no de resultados.</a:t>
             </a:r>
             <a:endParaRPr lang="en-US" dirty="0"/>
           </a:p>
@@ -2545,12 +2546,12 @@
           <a:p>
             <a:r>
               <a:rPr lang="en-US" dirty="0"/>
-              <a:t>Y aquí está el resultado que determina lo que finalmente se despliega.
-Las dos redes se evalúan contra líneas base no triviales: la solar contra la persistencia de cielo claro, la de precio contra la persistencia de veinticuatro horas, que es la referencia mínima que exigen las guías del campo. Ninguna la bate en el agregado de veinticuatro horas: la solar queda un ocho coma ocho por ciento por detrás, la de precio un siete coma uno.
-El diagnóstico es distinto en cada una. La solar predice irradiancia en bruto y tiene que reconstruir la geometría solar que la línea base recibe gratis: aporta hasta la cuarta hora y pierde después. La de precio ha aprendido el perfil calendario-solar, que es justo lo que la persistencia reproduce sin coste.
-Y detecté y corregí una realimentación del buffer de precio que degradaba el error un veintisiete coma siete por ciento. Todas las cifras de esta defensa son posteriores a esa corrección.
+              <a:t>Y aquí está el problema, el resultado que reorientó este capítulo.
+Cada red se evalúa contra su línea base: la solar contra la persistencia de cielo claro, la de precio contra la de veinticuatro horas. Y no es una vara de medir cualquiera: en estas dos series el día de hoy se parece muchísimo al de ayer, así que «lo mismo que ayer» acierta la mayor parte del tiempo. Es una referencia dura.
+Ninguna de las dos la bate: la solar queda un ocho coma ocho por ciento por detrás, la de precio un siete coma uno.
+Pero el motivo de esa derrota es lo que abre la solución. Una red recurrente está pensada para anticipar cambios, no para repetir lo de ayer. En las horas en que no cambia nada, que son la mayoría, la persistencia es imbatible; en las que sí cambia, que son las que deciden, aporta la red. Aciertan en sitios distintos: la salida no es elegir una, sino combinarlas.
 — — — — —
-NO SE DICE · objetivo 1:12 · Presentar esto como resultado medido, no como fallo. Es lo que demuestra que validaste contra la referencia correcta.</a:t>
+NO SE DICE · objetivo 1:13 · Presentar esto como resultado medido, no como fallo. Es lo que demuestra que validaste contra la referencia correcta.</a:t>
             </a:r>
             <a:endParaRPr lang="en-US" dirty="0"/>
           </a:p>
@@ -2639,9 +2640,10 @@
             <a:r>
               <a:rPr lang="en-US" dirty="0"/>
               <a:t>La solución tiene tres partes, y ninguna exige reentrenar.
-La primera es física: proyectar la predicción sobre la envolvente de cielo claro, es decir, no permitir que la irradiancia prevista supere a la de cielo despejado. Con eso el error diurno baja alrededor de un seis por ciento.
-La segunda es la que da nombre a la diapositiva: ponderar la red con su propia línea base. Una combinación convexa con un peso distinto por cada hora del horizonte, ajustado sobre validación, nunca sobre test. Los dos predictores cometen errores poco correlacionados —la red captura el perfil, la persistencia el nivel del día— y esa es la situación en la que combinar aporta. El resultado: más cinco coma ocho por ciento en solar y más seis coma seis en precio.
-Y la tercera es la corrección del lazo cerrado, realimentando con el precio real de la hora ya transcurrida, que sigue siendo estrictamente causal.
+La primera es física: acotar la predicción a la envolvente de cielo claro, no dejar que la irradiancia prevista supere la de un día despejado. Con eso el error absoluto medio diurno —cuánto me equivoco de media cada hora, en las unidades de la variable— baja de cincuenta y nueve a cincuenta y seis vatios-hora por metro cuadrado.
+La segunda da nombre a la diapositiva: ponderar la red con su propia línea base, una combinación convexa con un peso distinto por cada hora del horizonte, ajustado en validación y nunca en test.
+La tercera es la corrección del lazo cerrado, realimentando con el precio real de la hora ya transcurrida, que sigue siendo causal.
+El resultado son esas dos cifras, y conviene decir sobre qué se miden: no sobre no predecir nada, sino sobre la persistencia, que ya acierta la mayor parte del tiempo.
 — — — — —
 NO SE DICE · objetivo 1:08 · Esta es la diapositiva que cierra el bloque de redes. Deja claro que lo desplegado es la señal combinada.</a:t>
             </a:r>
@@ -3670,7 +3672,7 @@
         </p:nvSpPr>
         <p:spPr>
           <a:xfrm>
-            <a:off x="502920" y="2779776"/>
+            <a:off x="502920" y="2651760"/>
             <a:ext cx="1325880" cy="548640"/>
           </a:xfrm>
           <a:prstGeom prst="roundRect">
@@ -3697,7 +3699,7 @@
         </p:nvSpPr>
         <p:spPr>
           <a:xfrm>
-            <a:off x="502920" y="2779776"/>
+            <a:off x="502920" y="2651760"/>
             <a:ext cx="1325880" cy="548640"/>
           </a:xfrm>
           <a:prstGeom prst="rect">
@@ -3736,7 +3738,7 @@
         </p:nvSpPr>
         <p:spPr>
           <a:xfrm>
-            <a:off x="1892808" y="3054096"/>
+            <a:off x="1892808" y="2926080"/>
             <a:ext cx="365760" cy="0"/>
           </a:xfrm>
           <a:prstGeom prst="line">
@@ -3760,7 +3762,7 @@
         </p:nvSpPr>
         <p:spPr>
           <a:xfrm>
-            <a:off x="2322576" y="2596896"/>
+            <a:off x="2322576" y="2468880"/>
             <a:ext cx="2514600" cy="914400"/>
           </a:xfrm>
           <a:prstGeom prst="roundRect">
@@ -3787,7 +3789,7 @@
         </p:nvSpPr>
         <p:spPr>
           <a:xfrm>
-            <a:off x="2322576" y="2651760"/>
+            <a:off x="2322576" y="2523744"/>
             <a:ext cx="2514600" cy="475488"/>
           </a:xfrm>
           <a:prstGeom prst="rect">
@@ -3826,7 +3828,7 @@
         </p:nvSpPr>
         <p:spPr>
           <a:xfrm>
-            <a:off x="2377440" y="3072384"/>
+            <a:off x="2377440" y="2944368"/>
             <a:ext cx="2404872" cy="384048"/>
           </a:xfrm>
           <a:prstGeom prst="rect">
@@ -3868,7 +3870,7 @@
         </p:nvSpPr>
         <p:spPr>
           <a:xfrm>
-            <a:off x="4901184" y="3054096"/>
+            <a:off x="4901184" y="2926080"/>
             <a:ext cx="310896" cy="0"/>
           </a:xfrm>
           <a:prstGeom prst="line">
@@ -3891,8 +3893,8 @@
         </p:nvSpPr>
         <p:spPr>
           <a:xfrm>
-            <a:off x="5212080" y="2167128"/>
-            <a:ext cx="0" cy="1316736"/>
+            <a:off x="5212080" y="2194560"/>
+            <a:ext cx="0" cy="1463040"/>
           </a:xfrm>
           <a:prstGeom prst="line">
             <a:avLst/>
@@ -3914,7 +3916,7 @@
         </p:nvSpPr>
         <p:spPr>
           <a:xfrm>
-            <a:off x="5212080" y="2167128"/>
+            <a:off x="5212080" y="2194560"/>
             <a:ext cx="128016" cy="0"/>
           </a:xfrm>
           <a:prstGeom prst="line">
@@ -3938,31 +3940,7 @@
         </p:nvSpPr>
         <p:spPr>
           <a:xfrm>
-            <a:off x="5212080" y="3483864"/>
-            <a:ext cx="128016" cy="0"/>
-          </a:xfrm>
-          <a:prstGeom prst="line">
-            <a:avLst/>
-          </a:prstGeom>
-          <a:noFill/>
-          <a:ln w="12700">
-            <a:solidFill>
-              <a:srgbClr val="5F6B72"/>
-            </a:solidFill>
-            <a:prstDash val="solid"/>
-            <a:tailEnd type="triangle"/>
-          </a:ln>
-        </p:spPr>
-      </p:sp>
-      <p:sp>
-        <p:nvSpPr>
-          <p:cNvPr id="14" name="Shape 12"/>
-          <p:cNvSpPr/>
-          <p:nvPr/>
-        </p:nvSpPr>
-        <p:spPr>
-          <a:xfrm>
-            <a:off x="5340096" y="1892808"/>
+            <a:off x="5340096" y="1920240"/>
             <a:ext cx="1874520" cy="548640"/>
           </a:xfrm>
           <a:prstGeom prst="roundRect">
@@ -3983,13 +3961,13 @@
       </p:sp>
       <p:sp>
         <p:nvSpPr>
-          <p:cNvPr id="15" name="Text 13"/>
-          <p:cNvSpPr txBox="1"/>
-          <p:nvPr/>
-        </p:nvSpPr>
-        <p:spPr>
-          <a:xfrm>
-            <a:off x="5340096" y="1892808"/>
+          <p:cNvPr id="14" name="Text 12"/>
+          <p:cNvSpPr txBox="1"/>
+          <p:nvPr/>
+        </p:nvSpPr>
+        <p:spPr>
+          <a:xfrm>
+            <a:off x="5340096" y="1920240"/>
             <a:ext cx="1874520" cy="548640"/>
           </a:xfrm>
           <a:prstGeom prst="rect">
@@ -4019,6 +3997,30 @@
             <a:endParaRPr lang="en-US" sz="1250" dirty="0"/>
           </a:p>
         </p:txBody>
+      </p:sp>
+      <p:sp>
+        <p:nvSpPr>
+          <p:cNvPr id="15" name="Shape 13"/>
+          <p:cNvSpPr/>
+          <p:nvPr/>
+        </p:nvSpPr>
+        <p:spPr>
+          <a:xfrm>
+            <a:off x="5212080" y="2926080"/>
+            <a:ext cx="128016" cy="0"/>
+          </a:xfrm>
+          <a:prstGeom prst="line">
+            <a:avLst/>
+          </a:prstGeom>
+          <a:noFill/>
+          <a:ln w="12700">
+            <a:solidFill>
+              <a:srgbClr val="5F6B72"/>
+            </a:solidFill>
+            <a:prstDash val="solid"/>
+            <a:tailEnd type="triangle"/>
+          </a:ln>
+        </p:spPr>
       </p:sp>
       <p:sp>
         <p:nvSpPr>
@@ -4028,7 +4030,97 @@
         </p:nvSpPr>
         <p:spPr>
           <a:xfrm>
-            <a:off x="5340096" y="3209544"/>
+            <a:off x="5340096" y="2651760"/>
+            <a:ext cx="1874520" cy="548640"/>
+          </a:xfrm>
+          <a:prstGeom prst="roundRect">
+            <a:avLst>
+              <a:gd name="adj" fmla="val 10000"/>
+            </a:avLst>
+          </a:prstGeom>
+          <a:solidFill>
+            <a:srgbClr val="FFFFFF"/>
+          </a:solidFill>
+          <a:ln w="12700">
+            <a:solidFill>
+              <a:srgbClr val="DDE3E6"/>
+            </a:solidFill>
+            <a:prstDash val="solid"/>
+          </a:ln>
+        </p:spPr>
+      </p:sp>
+      <p:sp>
+        <p:nvSpPr>
+          <p:cNvPr id="17" name="Text 15"/>
+          <p:cNvSpPr txBox="1"/>
+          <p:nvPr/>
+        </p:nvSpPr>
+        <p:spPr>
+          <a:xfrm>
+            <a:off x="5340096" y="2651760"/>
+            <a:ext cx="1874520" cy="548640"/>
+          </a:xfrm>
+          <a:prstGeom prst="rect">
+            <a:avLst/>
+          </a:prstGeom>
+          <a:noFill/>
+          <a:ln/>
+        </p:spPr>
+        <p:txBody>
+          <a:bodyPr wrap="square" lIns="0" tIns="0" rIns="0" bIns="0" rtlCol="0" anchor="ctr"/>
+          <a:lstStyle/>
+          <a:p>
+            <a:pPr algn="ctr" indent="0" marL="0">
+              <a:buNone/>
+            </a:pPr>
+            <a:r>
+              <a:rPr lang="en-US" sz="1250" b="1" dirty="0">
+                <a:solidFill>
+                  <a:srgbClr val="10394A"/>
+                </a:solidFill>
+                <a:latin typeface="Calibri" pitchFamily="34" charset="0"/>
+                <a:ea typeface="Calibri" pitchFamily="34" charset="-122"/>
+                <a:cs typeface="Calibri" pitchFamily="34" charset="-120"/>
+              </a:rPr>
+              <a:t>Versión B</a:t>
+            </a:r>
+            <a:endParaRPr lang="en-US" sz="1250" dirty="0"/>
+          </a:p>
+        </p:txBody>
+      </p:sp>
+      <p:sp>
+        <p:nvSpPr>
+          <p:cNvPr id="18" name="Shape 16"/>
+          <p:cNvSpPr/>
+          <p:nvPr/>
+        </p:nvSpPr>
+        <p:spPr>
+          <a:xfrm>
+            <a:off x="5212080" y="3657600"/>
+            <a:ext cx="128016" cy="0"/>
+          </a:xfrm>
+          <a:prstGeom prst="line">
+            <a:avLst/>
+          </a:prstGeom>
+          <a:noFill/>
+          <a:ln w="12700">
+            <a:solidFill>
+              <a:srgbClr val="5F6B72"/>
+            </a:solidFill>
+            <a:prstDash val="solid"/>
+            <a:tailEnd type="triangle"/>
+          </a:ln>
+        </p:spPr>
+      </p:sp>
+      <p:sp>
+        <p:nvSpPr>
+          <p:cNvPr id="19" name="Shape 17"/>
+          <p:cNvSpPr/>
+          <p:nvPr/>
+        </p:nvSpPr>
+        <p:spPr>
+          <a:xfrm>
+            <a:off x="5340096" y="3383280"/>
             <a:ext cx="1874520" cy="548640"/>
           </a:xfrm>
           <a:prstGeom prst="roundRect">
@@ -4049,13 +4141,13 @@
       </p:sp>
       <p:sp>
         <p:nvSpPr>
-          <p:cNvPr id="17" name="Text 15"/>
-          <p:cNvSpPr txBox="1"/>
-          <p:nvPr/>
-        </p:nvSpPr>
-        <p:spPr>
-          <a:xfrm>
-            <a:off x="5340096" y="3209544"/>
+          <p:cNvPr id="20" name="Text 18"/>
+          <p:cNvSpPr txBox="1"/>
+          <p:nvPr/>
+        </p:nvSpPr>
+        <p:spPr>
+          <a:xfrm>
+            <a:off x="5340096" y="3383280"/>
             <a:ext cx="1874520" cy="548640"/>
           </a:xfrm>
           <a:prstGeom prst="rect">
@@ -4088,52 +4180,13 @@
       </p:sp>
       <p:sp>
         <p:nvSpPr>
-          <p:cNvPr id="18" name="Text 16"/>
-          <p:cNvSpPr txBox="1"/>
-          <p:nvPr/>
-        </p:nvSpPr>
-        <p:spPr>
-          <a:xfrm>
-            <a:off x="5340096" y="2487168"/>
-            <a:ext cx="1874520" cy="402336"/>
-          </a:xfrm>
-          <a:prstGeom prst="rect">
-            <a:avLst/>
-          </a:prstGeom>
-          <a:noFill/>
-          <a:ln/>
-        </p:spPr>
-        <p:txBody>
-          <a:bodyPr wrap="square" lIns="0" tIns="0" rIns="0" bIns="0" rtlCol="0" anchor="ctr"/>
-          <a:lstStyle/>
-          <a:p>
-            <a:pPr algn="ctr" indent="0" marL="0">
-              <a:buNone/>
-            </a:pPr>
-            <a:r>
-              <a:rPr lang="en-US" sz="1000" i="1" dirty="0">
-                <a:solidFill>
-                  <a:srgbClr val="C8861E"/>
-                </a:solidFill>
-                <a:latin typeface="Calibri" pitchFamily="34" charset="0"/>
-                <a:ea typeface="Calibri" pitchFamily="34" charset="-122"/>
-                <a:cs typeface="Calibri" pitchFamily="34" charset="-120"/>
-              </a:rPr>
-              <a:t>misma demanda, distinto gestor</a:t>
-            </a:r>
-            <a:endParaRPr lang="en-US" sz="1000" dirty="0"/>
-          </a:p>
-        </p:txBody>
-      </p:sp>
-      <p:sp>
-        <p:nvSpPr>
-          <p:cNvPr id="19" name="Shape 17"/>
+          <p:cNvPr id="21" name="Shape 19"/>
           <p:cNvSpPr/>
           <p:nvPr/>
         </p:nvSpPr>
         <p:spPr>
           <a:xfrm>
-            <a:off x="7278624" y="2167128"/>
+            <a:off x="7278624" y="2194560"/>
             <a:ext cx="374904" cy="0"/>
           </a:xfrm>
           <a:prstGeom prst="line">
@@ -4151,13 +4204,13 @@
       </p:sp>
       <p:sp>
         <p:nvSpPr>
-          <p:cNvPr id="20" name="Shape 18"/>
+          <p:cNvPr id="22" name="Shape 20"/>
           <p:cNvSpPr/>
           <p:nvPr/>
         </p:nvSpPr>
         <p:spPr>
           <a:xfrm>
-            <a:off x="7278624" y="3483864"/>
+            <a:off x="7278624" y="2926080"/>
             <a:ext cx="374904" cy="0"/>
           </a:xfrm>
           <a:prstGeom prst="line">
@@ -4175,37 +4228,14 @@
       </p:sp>
       <p:sp>
         <p:nvSpPr>
-          <p:cNvPr id="21" name="Shape 19"/>
+          <p:cNvPr id="23" name="Shape 21"/>
           <p:cNvSpPr/>
           <p:nvPr/>
         </p:nvSpPr>
         <p:spPr>
           <a:xfrm>
-            <a:off x="7653528" y="2167128"/>
-            <a:ext cx="0" cy="1316736"/>
-          </a:xfrm>
-          <a:prstGeom prst="line">
-            <a:avLst/>
-          </a:prstGeom>
-          <a:noFill/>
-          <a:ln w="12700">
-            <a:solidFill>
-              <a:srgbClr val="5F6B72"/>
-            </a:solidFill>
-            <a:prstDash val="solid"/>
-          </a:ln>
-        </p:spPr>
-      </p:sp>
-      <p:sp>
-        <p:nvSpPr>
-          <p:cNvPr id="22" name="Shape 20"/>
-          <p:cNvSpPr/>
-          <p:nvPr/>
-        </p:nvSpPr>
-        <p:spPr>
-          <a:xfrm>
-            <a:off x="7653528" y="3054096"/>
-            <a:ext cx="128016" cy="0"/>
+            <a:off x="7278624" y="3657600"/>
+            <a:ext cx="374904" cy="0"/>
           </a:xfrm>
           <a:prstGeom prst="line">
             <a:avLst/>
@@ -4222,13 +4252,60 @@
       </p:sp>
       <p:sp>
         <p:nvSpPr>
-          <p:cNvPr id="23" name="Shape 21"/>
+          <p:cNvPr id="24" name="Shape 22"/>
           <p:cNvSpPr/>
           <p:nvPr/>
         </p:nvSpPr>
         <p:spPr>
           <a:xfrm>
-            <a:off x="7781544" y="2596896"/>
+            <a:off x="7653528" y="2194560"/>
+            <a:ext cx="0" cy="1463040"/>
+          </a:xfrm>
+          <a:prstGeom prst="line">
+            <a:avLst/>
+          </a:prstGeom>
+          <a:noFill/>
+          <a:ln w="12700">
+            <a:solidFill>
+              <a:srgbClr val="5F6B72"/>
+            </a:solidFill>
+            <a:prstDash val="solid"/>
+          </a:ln>
+        </p:spPr>
+      </p:sp>
+      <p:sp>
+        <p:nvSpPr>
+          <p:cNvPr id="25" name="Shape 23"/>
+          <p:cNvSpPr/>
+          <p:nvPr/>
+        </p:nvSpPr>
+        <p:spPr>
+          <a:xfrm>
+            <a:off x="7653528" y="2926080"/>
+            <a:ext cx="128016" cy="0"/>
+          </a:xfrm>
+          <a:prstGeom prst="line">
+            <a:avLst/>
+          </a:prstGeom>
+          <a:noFill/>
+          <a:ln w="12700">
+            <a:solidFill>
+              <a:srgbClr val="5F6B72"/>
+            </a:solidFill>
+            <a:prstDash val="solid"/>
+            <a:tailEnd type="triangle"/>
+          </a:ln>
+        </p:spPr>
+      </p:sp>
+      <p:sp>
+        <p:nvSpPr>
+          <p:cNvPr id="26" name="Shape 24"/>
+          <p:cNvSpPr/>
+          <p:nvPr/>
+        </p:nvSpPr>
+        <p:spPr>
+          <a:xfrm>
+            <a:off x="7781544" y="2468880"/>
             <a:ext cx="2057400" cy="914400"/>
           </a:xfrm>
           <a:prstGeom prst="roundRect">
@@ -4249,13 +4326,13 @@
       </p:sp>
       <p:sp>
         <p:nvSpPr>
-          <p:cNvPr id="24" name="Text 22"/>
-          <p:cNvSpPr txBox="1"/>
-          <p:nvPr/>
-        </p:nvSpPr>
-        <p:spPr>
-          <a:xfrm>
-            <a:off x="7781544" y="2651760"/>
+          <p:cNvPr id="27" name="Text 25"/>
+          <p:cNvSpPr txBox="1"/>
+          <p:nvPr/>
+        </p:nvSpPr>
+        <p:spPr>
+          <a:xfrm>
+            <a:off x="7781544" y="2523744"/>
             <a:ext cx="2057400" cy="475488"/>
           </a:xfrm>
           <a:prstGeom prst="rect">
@@ -4280,7 +4357,7 @@
                 <a:ea typeface="Calibri" pitchFamily="34" charset="-122"/>
                 <a:cs typeface="Calibri" pitchFamily="34" charset="-120"/>
               </a:rPr>
-              <a:t>Diferencia del par</a:t>
+              <a:t>Diferencia entre dos versiones</a:t>
             </a:r>
             <a:endParaRPr lang="en-US" sz="1250" dirty="0"/>
           </a:p>
@@ -4288,13 +4365,13 @@
       </p:sp>
       <p:sp>
         <p:nvSpPr>
-          <p:cNvPr id="25" name="Text 23"/>
-          <p:cNvSpPr txBox="1"/>
-          <p:nvPr/>
-        </p:nvSpPr>
-        <p:spPr>
-          <a:xfrm>
-            <a:off x="7836408" y="3072384"/>
+          <p:cNvPr id="28" name="Text 26"/>
+          <p:cNvSpPr txBox="1"/>
+          <p:nvPr/>
+        </p:nvSpPr>
+        <p:spPr>
+          <a:xfrm>
+            <a:off x="7836408" y="2944368"/>
             <a:ext cx="1947672" cy="384048"/>
           </a:xfrm>
           <a:prstGeom prst="rect">
@@ -4322,7 +4399,7 @@
                 <a:ea typeface="Calibri" pitchFamily="34" charset="-122"/>
                 <a:cs typeface="Calibri" pitchFamily="34" charset="-120"/>
               </a:rPr>
-              <a:t>C − A, en euros por semana</a:t>
+              <a:t>sobre la misma semana, en euros</a:t>
             </a:r>
             <a:endParaRPr lang="en-US" sz="950" dirty="0"/>
           </a:p>
@@ -4330,13 +4407,13 @@
       </p:sp>
       <p:sp>
         <p:nvSpPr>
-          <p:cNvPr id="26" name="Text 24"/>
-          <p:cNvSpPr txBox="1"/>
-          <p:nvPr/>
-        </p:nvSpPr>
-        <p:spPr>
-          <a:xfrm>
-            <a:off x="10113264" y="2578608"/>
+          <p:cNvPr id="29" name="Text 27"/>
+          <p:cNvSpPr txBox="1"/>
+          <p:nvPr/>
+        </p:nvSpPr>
+        <p:spPr>
+          <a:xfrm>
+            <a:off x="10113264" y="2450592"/>
             <a:ext cx="1575511" cy="566928"/>
           </a:xfrm>
           <a:prstGeom prst="rect">
@@ -4369,13 +4446,13 @@
       </p:sp>
       <p:sp>
         <p:nvSpPr>
-          <p:cNvPr id="27" name="Text 25"/>
-          <p:cNvSpPr txBox="1"/>
-          <p:nvPr/>
-        </p:nvSpPr>
-        <p:spPr>
-          <a:xfrm>
-            <a:off x="10149840" y="3127248"/>
+          <p:cNvPr id="30" name="Text 28"/>
+          <p:cNvSpPr txBox="1"/>
+          <p:nvPr/>
+        </p:nvSpPr>
+        <p:spPr>
+          <a:xfrm>
+            <a:off x="10149840" y="2999232"/>
             <a:ext cx="1575511" cy="310896"/>
           </a:xfrm>
           <a:prstGeom prst="rect">
@@ -4408,13 +4485,13 @@
       </p:sp>
       <p:sp>
         <p:nvSpPr>
-          <p:cNvPr id="28" name="Text 26"/>
-          <p:cNvSpPr txBox="1"/>
-          <p:nvPr/>
-        </p:nvSpPr>
-        <p:spPr>
-          <a:xfrm>
-            <a:off x="502920" y="3968496"/>
+          <p:cNvPr id="31" name="Text 29"/>
+          <p:cNvSpPr txBox="1"/>
+          <p:nvPr/>
+        </p:nvSpPr>
+        <p:spPr>
+          <a:xfrm>
+            <a:off x="502920" y="4096512"/>
             <a:ext cx="11185855" cy="310896"/>
           </a:xfrm>
           <a:prstGeom prst="rect">
@@ -4439,7 +4516,7 @@
                 <a:ea typeface="Calibri" pitchFamily="34" charset="-122"/>
                 <a:cs typeface="Calibri" pitchFamily="34" charset="-120"/>
               </a:rPr>
-              <a:t>El ruido de la demanda es común a los dos miembros del par y se cancela en la resta: el contraste se hace sobre las 20 diferencias, no sobre dos medias.</a:t>
+              <a:t>La misma semilla corre en todas las versiones, así que el azar de la demanda se cancela en la resta: el contraste se hace sobre las 20 diferencias, no sobre dos promedios.</a:t>
             </a:r>
             <a:endParaRPr lang="en-US" sz="1150" dirty="0"/>
           </a:p>
@@ -4447,7 +4524,7 @@
       </p:sp>
       <p:sp>
         <p:nvSpPr>
-          <p:cNvPr id="29" name="Shape 27"/>
+          <p:cNvPr id="32" name="Shape 30"/>
           <p:cNvSpPr/>
           <p:nvPr/>
         </p:nvSpPr>
@@ -4470,7 +4547,7 @@
       </p:sp>
       <p:sp>
         <p:nvSpPr>
-          <p:cNvPr id="30" name="Text 28"/>
+          <p:cNvPr id="33" name="Text 31"/>
           <p:cNvSpPr txBox="1"/>
           <p:nvPr/>
         </p:nvSpPr>
@@ -4501,7 +4578,7 @@
                 <a:ea typeface="Cambria" pitchFamily="34" charset="-122"/>
                 <a:cs typeface="Cambria" pitchFamily="34" charset="-120"/>
               </a:rPr>
-              <a:t>Pareado por semilla</a:t>
+              <a:t>Comparar en pareja</a:t>
             </a:r>
             <a:endParaRPr lang="en-US" sz="1500" dirty="0"/>
           </a:p>
@@ -4509,7 +4586,7 @@
       </p:sp>
       <p:sp>
         <p:nvSpPr>
-          <p:cNvPr id="31" name="Text 29"/>
+          <p:cNvPr id="34" name="Text 32"/>
           <p:cNvSpPr txBox="1"/>
           <p:nvPr/>
         </p:nvSpPr>
@@ -4543,7 +4620,7 @@
                 <a:ea typeface="Calibri" pitchFamily="34" charset="-122"/>
                 <a:cs typeface="Calibri" pitchFamily="34" charset="-120"/>
               </a:rPr>
-              <a:t>La semilla n genera exactamente el mismo perfil de demanda en todas las versiones</a:t>
+              <a:t>Cada versión se mide contra otra sobre la misma semana, no contra un promedio</a:t>
             </a:r>
             <a:endParaRPr lang="en-US" sz="1200" dirty="0"/>
           </a:p>
@@ -4551,7 +4628,7 @@
       </p:sp>
       <p:sp>
         <p:nvSpPr>
-          <p:cNvPr id="32" name="Text 30"/>
+          <p:cNvPr id="35" name="Text 33"/>
           <p:cNvSpPr txBox="1"/>
           <p:nvPr/>
         </p:nvSpPr>
@@ -4590,7 +4667,7 @@
       </p:sp>
       <p:sp>
         <p:nvSpPr>
-          <p:cNvPr id="33" name="Text 31"/>
+          <p:cNvPr id="36" name="Text 34"/>
           <p:cNvSpPr txBox="1"/>
           <p:nvPr/>
         </p:nvSpPr>
@@ -4624,7 +4701,7 @@
                 <a:ea typeface="Calibri" pitchFamily="34" charset="-122"/>
                 <a:cs typeface="Calibri" pitchFamily="34" charset="-120"/>
               </a:rPr>
-              <a:t>Rangos con signo, no medias: tres semillas nubladas llegaban a dominarlas</a:t>
+              <a:t>Mira si las diferencias caen siempre del mismo lado, en vez de promediarlas</a:t>
             </a:r>
             <a:endParaRPr lang="en-US" sz="1200" dirty="0"/>
           </a:p>
@@ -4632,7 +4709,7 @@
       </p:sp>
       <p:sp>
         <p:nvSpPr>
-          <p:cNvPr id="34" name="Text 32"/>
+          <p:cNvPr id="37" name="Text 35"/>
           <p:cNvSpPr txBox="1"/>
           <p:nvPr/>
         </p:nvSpPr>
@@ -4671,7 +4748,7 @@
       </p:sp>
       <p:sp>
         <p:nvSpPr>
-          <p:cNvPr id="35" name="Text 33"/>
+          <p:cNvPr id="38" name="Text 36"/>
           <p:cNvSpPr txBox="1"/>
           <p:nvPr/>
         </p:nvSpPr>
@@ -4705,7 +4782,7 @@
                 <a:ea typeface="Calibri" pitchFamily="34" charset="-122"/>
                 <a:cs typeface="Calibri" pitchFamily="34" charset="-120"/>
               </a:rPr>
-              <a:t>9,33 €/semana, la dispersión de la propia referencia. Fijado antes de simular</a:t>
+              <a:t>Por debajo de 9,33 €/semana lo doy por empate. Fijado antes de simular</a:t>
             </a:r>
             <a:endParaRPr lang="en-US" sz="1200" dirty="0"/>
           </a:p>
@@ -4713,7 +4790,7 @@
       </p:sp>
       <p:sp>
         <p:nvSpPr>
-          <p:cNvPr id="36" name="Text 34"/>
+          <p:cNvPr id="39" name="Text 37"/>
           <p:cNvSpPr txBox="1"/>
           <p:nvPr/>
         </p:nvSpPr>
@@ -4752,7 +4829,7 @@
       </p:sp>
       <p:sp>
         <p:nvSpPr>
-          <p:cNvPr id="37" name="Text 35"/>
+          <p:cNvPr id="40" name="Text 38"/>
           <p:cNvSpPr txBox="1"/>
           <p:nvPr/>
         </p:nvSpPr>
@@ -4786,7 +4863,7 @@
                 <a:ea typeface="Calibri" pitchFamily="34" charset="-122"/>
                 <a:cs typeface="Calibri" pitchFamily="34" charset="-120"/>
               </a:rPr>
-              <a:t>La misma tanda con la previsión perfecta: es la cota superior, no una versión</a:t>
+              <a:t>La misma tanda con previsión perfecta: marca el techo de lo alcanzable</a:t>
             </a:r>
             <a:endParaRPr lang="en-US" sz="1200" dirty="0"/>
           </a:p>
@@ -4794,7 +4871,7 @@
       </p:sp>
       <p:sp>
         <p:nvSpPr>
-          <p:cNvPr id="38" name="Text 36"/>
+          <p:cNvPr id="41" name="Text 39"/>
           <p:cNvSpPr txBox="1"/>
           <p:nvPr/>
         </p:nvSpPr>
@@ -5257,7 +5334,7 @@
                 <a:ea typeface="Calibri" pitchFamily="34" charset="-122"/>
                 <a:cs typeface="Calibri" pitchFamily="34" charset="-120"/>
               </a:rPr>
-              <a:t>Tanque tampón, compresor y tanque surtidor con sus umbrales</a:t>
+              <a:t>Tanque pulmón, compresor y tanque surtidor con sus umbrales</a:t>
             </a:r>
             <a:endParaRPr lang="en-US" sz="1350" dirty="0"/>
           </a:p>
@@ -6520,7 +6597,7 @@
                 <a:ea typeface="Calibri" pitchFamily="34" charset="-122"/>
                 <a:cs typeface="Calibri" pitchFamily="34" charset="-120"/>
               </a:rPr>
-              <a:t>La información necesaria ya estaba en las entradas de la Versión A: ninguna previsión hacía falta para ver esto.</a:t>
+              <a:t>En esa misma semana la estación exporta 14 012 kWh a 39,3 €/MWh: vende diez veces más energía de la que compra, y la compra tres veces más cara.</a:t>
             </a:r>
             <a:endParaRPr lang="en-US" sz="1350" dirty="0"/>
           </a:p>
@@ -6678,56 +6755,32 @@
           </a:p>
         </p:txBody>
       </p:sp>
-      <p:pic>
-        <p:nvPicPr>
-          <p:cNvPr id="4" name="Image 0" descr="img/ems_logica_C.png">    </p:cNvPr>
-          <p:cNvPicPr>
-            <a:picLocks noChangeAspect="1"/>
-          </p:cNvPicPr>
-          <p:nvPr/>
-        </p:nvPicPr>
-        <p:blipFill>
-          <a:blip r:embed="rId1"/>
-          <a:stretch>
-            <a:fillRect/>
-          </a:stretch>
-        </p:blipFill>
-        <p:spPr>
-          <a:xfrm>
-            <a:off x="754380" y="1536192"/>
-            <a:ext cx="6217920" cy="3886200"/>
-          </a:xfrm>
-          <a:prstGeom prst="rect">
-            <a:avLst/>
-          </a:prstGeom>
-        </p:spPr>
-      </p:pic>
-      <p:sp>
-        <p:nvSpPr>
-          <p:cNvPr id="5" name="Text 2"/>
-          <p:cNvSpPr txBox="1"/>
-          <p:nvPr/>
-        </p:nvSpPr>
-        <p:spPr>
-          <a:xfrm>
-            <a:off x="7498080" y="1536192"/>
-            <a:ext cx="4206240" cy="274320"/>
-          </a:xfrm>
-          <a:prstGeom prst="rect">
-            <a:avLst/>
-          </a:prstGeom>
-          <a:noFill/>
-          <a:ln/>
-        </p:spPr>
-        <p:txBody>
-          <a:bodyPr wrap="square" lIns="0" tIns="0" rIns="0" bIns="0" rtlCol="0" anchor="ctr"/>
-          <a:lstStyle/>
-          <a:p>
-            <a:pPr indent="0" marL="0">
-              <a:buNone/>
-            </a:pPr>
-            <a:r>
-              <a:rPr lang="en-US" sz="1000" b="1" spc="140" kern="0" dirty="0">
+      <p:sp>
+        <p:nvSpPr>
+          <p:cNvPr id="4" name="Text 2"/>
+          <p:cNvSpPr txBox="1"/>
+          <p:nvPr/>
+        </p:nvSpPr>
+        <p:spPr>
+          <a:xfrm>
+            <a:off x="502920" y="1517904"/>
+            <a:ext cx="11185855" cy="256032"/>
+          </a:xfrm>
+          <a:prstGeom prst="rect">
+            <a:avLst/>
+          </a:prstGeom>
+          <a:noFill/>
+          <a:ln/>
+        </p:spPr>
+        <p:txBody>
+          <a:bodyPr wrap="square" lIns="0" tIns="0" rIns="0" bIns="0" rtlCol="0" anchor="ctr"/>
+          <a:lstStyle/>
+          <a:p>
+            <a:pPr indent="0" marL="0">
+              <a:buNone/>
+            </a:pPr>
+            <a:r>
+              <a:rPr lang="en-US" sz="1050" b="1" spc="130" kern="0" dirty="0">
                 <a:solidFill>
                   <a:srgbClr val="C8861E"/>
                 </a:solidFill>
@@ -6735,77 +6788,913 @@
                 <a:ea typeface="Calibri" pitchFamily="34" charset="-122"/>
                 <a:cs typeface="Calibri" pitchFamily="34" charset="-120"/>
               </a:rPr>
-              <a:t>VERSIÓN C · dos cambios, cada uno con su interruptor</a:t>
-            </a:r>
-            <a:endParaRPr lang="en-US" sz="1000" dirty="0"/>
-          </a:p>
-        </p:txBody>
-      </p:sp>
-      <p:sp>
-        <p:nvSpPr>
-          <p:cNvPr id="6" name="Text 3"/>
-          <p:cNvSpPr txBox="1"/>
-          <p:nvPr/>
-        </p:nvSpPr>
-        <p:spPr>
-          <a:xfrm>
-            <a:off x="7498080" y="1993392"/>
-            <a:ext cx="320040" cy="320040"/>
-          </a:xfrm>
-          <a:prstGeom prst="rect">
-            <a:avLst/>
-          </a:prstGeom>
-          <a:noFill/>
-          <a:ln/>
-        </p:spPr>
-        <p:txBody>
-          <a:bodyPr wrap="square" lIns="0" tIns="0" rIns="0" bIns="0" rtlCol="0" anchor="ctr"/>
-          <a:lstStyle/>
-          <a:p>
-            <a:pPr indent="0" marL="0">
-              <a:buNone/>
-            </a:pPr>
-            <a:r>
-              <a:rPr lang="en-US" sz="1700" b="1" dirty="0">
-                <a:solidFill>
-                  <a:srgbClr val="C8861E"/>
+              <a:t>La lógica común, en cuatro pasos · la Versión C sustituye dos de ellos</a:t>
+            </a:r>
+            <a:endParaRPr lang="en-US" sz="1050" dirty="0"/>
+          </a:p>
+        </p:txBody>
+      </p:sp>
+      <p:sp>
+        <p:nvSpPr>
+          <p:cNvPr id="5" name="Shape 3"/>
+          <p:cNvSpPr/>
+          <p:nvPr/>
+        </p:nvSpPr>
+        <p:spPr>
+          <a:xfrm>
+            <a:off x="502920" y="1901952"/>
+            <a:ext cx="2631872" cy="1188720"/>
+          </a:xfrm>
+          <a:prstGeom prst="roundRect">
+            <a:avLst>
+              <a:gd name="adj" fmla="val 3846"/>
+            </a:avLst>
+          </a:prstGeom>
+          <a:solidFill>
+            <a:srgbClr val="F1F5F7"/>
+          </a:solidFill>
+          <a:ln w="12700">
+            <a:solidFill>
+              <a:srgbClr val="DDE3E6"/>
+            </a:solidFill>
+            <a:prstDash val="solid"/>
+          </a:ln>
+        </p:spPr>
+      </p:sp>
+      <p:sp>
+        <p:nvSpPr>
+          <p:cNvPr id="6" name="Text 4"/>
+          <p:cNvSpPr txBox="1"/>
+          <p:nvPr/>
+        </p:nvSpPr>
+        <p:spPr>
+          <a:xfrm>
+            <a:off x="667512" y="2029968"/>
+            <a:ext cx="2302688" cy="292608"/>
+          </a:xfrm>
+          <a:prstGeom prst="rect">
+            <a:avLst/>
+          </a:prstGeom>
+          <a:noFill/>
+          <a:ln/>
+        </p:spPr>
+        <p:txBody>
+          <a:bodyPr wrap="square" lIns="0" tIns="0" rIns="0" bIns="0" rtlCol="0" anchor="ctr"/>
+          <a:lstStyle/>
+          <a:p>
+            <a:pPr indent="0" marL="0">
+              <a:buNone/>
+            </a:pPr>
+            <a:r>
+              <a:rPr lang="en-US" sz="1300" b="1" dirty="0">
+                <a:solidFill>
+                  <a:srgbClr val="10394A"/>
+                </a:solidFill>
+                <a:latin typeface="Calibri" pitchFamily="34" charset="0"/>
+                <a:ea typeface="Calibri" pitchFamily="34" charset="-122"/>
+                <a:cs typeface="Calibri" pitchFamily="34" charset="-120"/>
+              </a:rPr>
+              <a:t>1 · Balance</a:t>
+            </a:r>
+            <a:endParaRPr lang="en-US" sz="1300" dirty="0"/>
+          </a:p>
+        </p:txBody>
+      </p:sp>
+      <p:sp>
+        <p:nvSpPr>
+          <p:cNvPr id="7" name="Text 5"/>
+          <p:cNvSpPr txBox="1"/>
+          <p:nvPr/>
+        </p:nvSpPr>
+        <p:spPr>
+          <a:xfrm>
+            <a:off x="667512" y="2359152"/>
+            <a:ext cx="2302688" cy="621792"/>
+          </a:xfrm>
+          <a:prstGeom prst="rect">
+            <a:avLst/>
+          </a:prstGeom>
+          <a:noFill/>
+          <a:ln/>
+        </p:spPr>
+        <p:txBody>
+          <a:bodyPr wrap="square" lIns="0" tIns="0" rIns="0" bIns="0" rtlCol="0" anchor="t"/>
+          <a:lstStyle/>
+          <a:p>
+            <a:pPr indent="0" marL="0">
+              <a:lnSpc>
+                <a:spcPct val="112000"/>
+              </a:lnSpc>
+              <a:buNone/>
+            </a:pPr>
+            <a:r>
+              <a:rPr lang="en-US" sz="1100" dirty="0">
+                <a:solidFill>
+                  <a:srgbClr val="5F6B72"/>
+                </a:solidFill>
+                <a:latin typeface="Calibri" pitchFamily="34" charset="0"/>
+                <a:ea typeface="Calibri" pitchFamily="34" charset="-122"/>
+                <a:cs typeface="Calibri" pitchFamily="34" charset="-120"/>
+              </a:rPr>
+              <a:t>Excedente = fotovoltaica − carga</a:t>
+            </a:r>
+            <a:endParaRPr lang="en-US" sz="1100" dirty="0"/>
+          </a:p>
+        </p:txBody>
+      </p:sp>
+      <p:sp>
+        <p:nvSpPr>
+          <p:cNvPr id="8" name="Shape 6"/>
+          <p:cNvSpPr/>
+          <p:nvPr/>
+        </p:nvSpPr>
+        <p:spPr>
+          <a:xfrm>
+            <a:off x="3162224" y="2496312"/>
+            <a:ext cx="164592" cy="0"/>
+          </a:xfrm>
+          <a:prstGeom prst="line">
+            <a:avLst/>
+          </a:prstGeom>
+          <a:noFill/>
+          <a:ln w="12700">
+            <a:solidFill>
+              <a:srgbClr val="5F6B72"/>
+            </a:solidFill>
+            <a:prstDash val="solid"/>
+            <a:tailEnd type="triangle"/>
+          </a:ln>
+        </p:spPr>
+      </p:sp>
+      <p:sp>
+        <p:nvSpPr>
+          <p:cNvPr id="9" name="Shape 7"/>
+          <p:cNvSpPr/>
+          <p:nvPr/>
+        </p:nvSpPr>
+        <p:spPr>
+          <a:xfrm>
+            <a:off x="3354248" y="1901952"/>
+            <a:ext cx="2631872" cy="1188720"/>
+          </a:xfrm>
+          <a:prstGeom prst="roundRect">
+            <a:avLst>
+              <a:gd name="adj" fmla="val 3846"/>
+            </a:avLst>
+          </a:prstGeom>
+          <a:solidFill>
+            <a:srgbClr val="F1F5F7"/>
+          </a:solidFill>
+          <a:ln w="12700">
+            <a:solidFill>
+              <a:srgbClr val="DDE3E6"/>
+            </a:solidFill>
+            <a:prstDash val="solid"/>
+          </a:ln>
+        </p:spPr>
+      </p:sp>
+      <p:sp>
+        <p:nvSpPr>
+          <p:cNvPr id="10" name="Text 8"/>
+          <p:cNvSpPr txBox="1"/>
+          <p:nvPr/>
+        </p:nvSpPr>
+        <p:spPr>
+          <a:xfrm>
+            <a:off x="3518840" y="2029968"/>
+            <a:ext cx="2302688" cy="292608"/>
+          </a:xfrm>
+          <a:prstGeom prst="rect">
+            <a:avLst/>
+          </a:prstGeom>
+          <a:noFill/>
+          <a:ln/>
+        </p:spPr>
+        <p:txBody>
+          <a:bodyPr wrap="square" lIns="0" tIns="0" rIns="0" bIns="0" rtlCol="0" anchor="ctr"/>
+          <a:lstStyle/>
+          <a:p>
+            <a:pPr indent="0" marL="0">
+              <a:buNone/>
+            </a:pPr>
+            <a:r>
+              <a:rPr lang="en-US" sz="1300" b="1" dirty="0">
+                <a:solidFill>
+                  <a:srgbClr val="10394A"/>
+                </a:solidFill>
+                <a:latin typeface="Calibri" pitchFamily="34" charset="0"/>
+                <a:ea typeface="Calibri" pitchFamily="34" charset="-122"/>
+                <a:cs typeface="Calibri" pitchFamily="34" charset="-120"/>
+              </a:rPr>
+              <a:t>2 · Sobra energía</a:t>
+            </a:r>
+            <a:endParaRPr lang="en-US" sz="1300" dirty="0"/>
+          </a:p>
+        </p:txBody>
+      </p:sp>
+      <p:sp>
+        <p:nvSpPr>
+          <p:cNvPr id="11" name="Text 9"/>
+          <p:cNvSpPr txBox="1"/>
+          <p:nvPr/>
+        </p:nvSpPr>
+        <p:spPr>
+          <a:xfrm>
+            <a:off x="3518840" y="2359152"/>
+            <a:ext cx="2302688" cy="621792"/>
+          </a:xfrm>
+          <a:prstGeom prst="rect">
+            <a:avLst/>
+          </a:prstGeom>
+          <a:noFill/>
+          <a:ln/>
+        </p:spPr>
+        <p:txBody>
+          <a:bodyPr wrap="square" lIns="0" tIns="0" rIns="0" bIns="0" rtlCol="0" anchor="t"/>
+          <a:lstStyle/>
+          <a:p>
+            <a:pPr indent="0" marL="0">
+              <a:lnSpc>
+                <a:spcPct val="112000"/>
+              </a:lnSpc>
+              <a:buNone/>
+            </a:pPr>
+            <a:r>
+              <a:rPr lang="en-US" sz="1100" dirty="0">
+                <a:solidFill>
+                  <a:srgbClr val="5F6B72"/>
+                </a:solidFill>
+                <a:latin typeface="Calibri" pitchFamily="34" charset="0"/>
+                <a:ea typeface="Calibri" pitchFamily="34" charset="-122"/>
+                <a:cs typeface="Calibri" pitchFamily="34" charset="-120"/>
+              </a:rPr>
+              <a:t>Repartir entre batería y electrolizador según el estado de carga</a:t>
+            </a:r>
+            <a:endParaRPr lang="en-US" sz="1100" dirty="0"/>
+          </a:p>
+        </p:txBody>
+      </p:sp>
+      <p:sp>
+        <p:nvSpPr>
+          <p:cNvPr id="12" name="Shape 10"/>
+          <p:cNvSpPr/>
+          <p:nvPr/>
+        </p:nvSpPr>
+        <p:spPr>
+          <a:xfrm>
+            <a:off x="6013552" y="2496312"/>
+            <a:ext cx="164592" cy="0"/>
+          </a:xfrm>
+          <a:prstGeom prst="line">
+            <a:avLst/>
+          </a:prstGeom>
+          <a:noFill/>
+          <a:ln w="12700">
+            <a:solidFill>
+              <a:srgbClr val="5F6B72"/>
+            </a:solidFill>
+            <a:prstDash val="solid"/>
+            <a:tailEnd type="triangle"/>
+          </a:ln>
+        </p:spPr>
+      </p:sp>
+      <p:sp>
+        <p:nvSpPr>
+          <p:cNvPr id="13" name="Shape 11"/>
+          <p:cNvSpPr/>
+          <p:nvPr/>
+        </p:nvSpPr>
+        <p:spPr>
+          <a:xfrm>
+            <a:off x="6205576" y="1901952"/>
+            <a:ext cx="2631872" cy="1188720"/>
+          </a:xfrm>
+          <a:prstGeom prst="roundRect">
+            <a:avLst>
+              <a:gd name="adj" fmla="val 3846"/>
+            </a:avLst>
+          </a:prstGeom>
+          <a:solidFill>
+            <a:srgbClr val="FFFFFF"/>
+          </a:solidFill>
+          <a:ln w="19050">
+            <a:solidFill>
+              <a:srgbClr val="C8861E"/>
+            </a:solidFill>
+            <a:prstDash val="solid"/>
+          </a:ln>
+        </p:spPr>
+      </p:sp>
+      <p:sp>
+        <p:nvSpPr>
+          <p:cNvPr id="14" name="Text 12"/>
+          <p:cNvSpPr txBox="1"/>
+          <p:nvPr/>
+        </p:nvSpPr>
+        <p:spPr>
+          <a:xfrm>
+            <a:off x="6370168" y="2029968"/>
+            <a:ext cx="2302688" cy="292608"/>
+          </a:xfrm>
+          <a:prstGeom prst="rect">
+            <a:avLst/>
+          </a:prstGeom>
+          <a:noFill/>
+          <a:ln/>
+        </p:spPr>
+        <p:txBody>
+          <a:bodyPr wrap="square" lIns="0" tIns="0" rIns="0" bIns="0" rtlCol="0" anchor="ctr"/>
+          <a:lstStyle/>
+          <a:p>
+            <a:pPr indent="0" marL="0">
+              <a:buNone/>
+            </a:pPr>
+            <a:r>
+              <a:rPr lang="en-US" sz="1300" b="1" dirty="0">
+                <a:solidFill>
+                  <a:srgbClr val="10394A"/>
+                </a:solidFill>
+                <a:latin typeface="Calibri" pitchFamily="34" charset="0"/>
+                <a:ea typeface="Calibri" pitchFamily="34" charset="-122"/>
+                <a:cs typeface="Calibri" pitchFamily="34" charset="-120"/>
+              </a:rPr>
+              <a:t>3 · Falta energía</a:t>
+            </a:r>
+            <a:endParaRPr lang="en-US" sz="1300" dirty="0"/>
+          </a:p>
+        </p:txBody>
+      </p:sp>
+      <p:sp>
+        <p:nvSpPr>
+          <p:cNvPr id="15" name="Text 13"/>
+          <p:cNvSpPr txBox="1"/>
+          <p:nvPr/>
+        </p:nvSpPr>
+        <p:spPr>
+          <a:xfrm>
+            <a:off x="6370168" y="2359152"/>
+            <a:ext cx="2302688" cy="621792"/>
+          </a:xfrm>
+          <a:prstGeom prst="rect">
+            <a:avLst/>
+          </a:prstGeom>
+          <a:noFill/>
+          <a:ln/>
+        </p:spPr>
+        <p:txBody>
+          <a:bodyPr wrap="square" lIns="0" tIns="0" rIns="0" bIns="0" rtlCol="0" anchor="t"/>
+          <a:lstStyle/>
+          <a:p>
+            <a:pPr indent="0" marL="0">
+              <a:lnSpc>
+                <a:spcPct val="112000"/>
+              </a:lnSpc>
+              <a:buNone/>
+            </a:pPr>
+            <a:r>
+              <a:rPr lang="en-US" sz="1100" dirty="0">
+                <a:solidFill>
+                  <a:srgbClr val="5F6B72"/>
+                </a:solidFill>
+                <a:latin typeface="Calibri" pitchFamily="34" charset="0"/>
+                <a:ea typeface="Calibri" pitchFamily="34" charset="-122"/>
+                <a:cs typeface="Calibri" pitchFamily="34" charset="-120"/>
+              </a:rPr>
+              <a:t>Cubrir el déficit por orden: batería, pila, red</a:t>
+            </a:r>
+            <a:endParaRPr lang="en-US" sz="1100" dirty="0"/>
+          </a:p>
+        </p:txBody>
+      </p:sp>
+      <p:sp>
+        <p:nvSpPr>
+          <p:cNvPr id="16" name="Shape 14"/>
+          <p:cNvSpPr/>
+          <p:nvPr/>
+        </p:nvSpPr>
+        <p:spPr>
+          <a:xfrm>
+            <a:off x="8453399" y="1755648"/>
+            <a:ext cx="310896" cy="310896"/>
+          </a:xfrm>
+          <a:prstGeom prst="ellipse">
+            <a:avLst/>
+          </a:prstGeom>
+          <a:solidFill>
+            <a:srgbClr val="C8861E"/>
+          </a:solidFill>
+          <a:ln/>
+        </p:spPr>
+      </p:sp>
+      <p:sp>
+        <p:nvSpPr>
+          <p:cNvPr id="17" name="Text 15"/>
+          <p:cNvSpPr txBox="1"/>
+          <p:nvPr/>
+        </p:nvSpPr>
+        <p:spPr>
+          <a:xfrm>
+            <a:off x="8453399" y="1755648"/>
+            <a:ext cx="310896" cy="310896"/>
+          </a:xfrm>
+          <a:prstGeom prst="rect">
+            <a:avLst/>
+          </a:prstGeom>
+          <a:noFill/>
+          <a:ln/>
+        </p:spPr>
+        <p:txBody>
+          <a:bodyPr wrap="square" lIns="0" tIns="0" rIns="0" bIns="0" rtlCol="0" anchor="ctr"/>
+          <a:lstStyle/>
+          <a:p>
+            <a:pPr algn="ctr" indent="0" marL="0">
+              <a:buNone/>
+            </a:pPr>
+            <a:r>
+              <a:rPr lang="en-US" sz="1200" b="1" dirty="0">
+                <a:solidFill>
+                  <a:srgbClr val="10394A"/>
+                </a:solidFill>
+                <a:latin typeface="Calibri" pitchFamily="34" charset="0"/>
+                <a:ea typeface="Calibri" pitchFamily="34" charset="-122"/>
+                <a:cs typeface="Calibri" pitchFamily="34" charset="-120"/>
+              </a:rPr>
+              <a:t>1</a:t>
+            </a:r>
+            <a:endParaRPr lang="en-US" sz="1200" dirty="0"/>
+          </a:p>
+        </p:txBody>
+      </p:sp>
+      <p:sp>
+        <p:nvSpPr>
+          <p:cNvPr id="18" name="Shape 16"/>
+          <p:cNvSpPr/>
+          <p:nvPr/>
+        </p:nvSpPr>
+        <p:spPr>
+          <a:xfrm>
+            <a:off x="8864879" y="2496312"/>
+            <a:ext cx="164592" cy="0"/>
+          </a:xfrm>
+          <a:prstGeom prst="line">
+            <a:avLst/>
+          </a:prstGeom>
+          <a:noFill/>
+          <a:ln w="12700">
+            <a:solidFill>
+              <a:srgbClr val="5F6B72"/>
+            </a:solidFill>
+            <a:prstDash val="solid"/>
+            <a:tailEnd type="triangle"/>
+          </a:ln>
+        </p:spPr>
+      </p:sp>
+      <p:sp>
+        <p:nvSpPr>
+          <p:cNvPr id="19" name="Shape 17"/>
+          <p:cNvSpPr/>
+          <p:nvPr/>
+        </p:nvSpPr>
+        <p:spPr>
+          <a:xfrm>
+            <a:off x="9056903" y="1901952"/>
+            <a:ext cx="2631872" cy="1188720"/>
+          </a:xfrm>
+          <a:prstGeom prst="roundRect">
+            <a:avLst>
+              <a:gd name="adj" fmla="val 3846"/>
+            </a:avLst>
+          </a:prstGeom>
+          <a:solidFill>
+            <a:srgbClr val="FFFFFF"/>
+          </a:solidFill>
+          <a:ln w="19050">
+            <a:solidFill>
+              <a:srgbClr val="C8861E"/>
+            </a:solidFill>
+            <a:prstDash val="solid"/>
+          </a:ln>
+        </p:spPr>
+      </p:sp>
+      <p:sp>
+        <p:nvSpPr>
+          <p:cNvPr id="20" name="Text 18"/>
+          <p:cNvSpPr txBox="1"/>
+          <p:nvPr/>
+        </p:nvSpPr>
+        <p:spPr>
+          <a:xfrm>
+            <a:off x="9221495" y="2029968"/>
+            <a:ext cx="2302688" cy="292608"/>
+          </a:xfrm>
+          <a:prstGeom prst="rect">
+            <a:avLst/>
+          </a:prstGeom>
+          <a:noFill/>
+          <a:ln/>
+        </p:spPr>
+        <p:txBody>
+          <a:bodyPr wrap="square" lIns="0" tIns="0" rIns="0" bIns="0" rtlCol="0" anchor="ctr"/>
+          <a:lstStyle/>
+          <a:p>
+            <a:pPr indent="0" marL="0">
+              <a:buNone/>
+            </a:pPr>
+            <a:r>
+              <a:rPr lang="en-US" sz="1300" b="1" dirty="0">
+                <a:solidFill>
+                  <a:srgbClr val="10394A"/>
+                </a:solidFill>
+                <a:latin typeface="Calibri" pitchFamily="34" charset="0"/>
+                <a:ea typeface="Calibri" pitchFamily="34" charset="-122"/>
+                <a:cs typeface="Calibri" pitchFamily="34" charset="-120"/>
+              </a:rPr>
+              <a:t>4 · ¿Producir H₂?</a:t>
+            </a:r>
+            <a:endParaRPr lang="en-US" sz="1300" dirty="0"/>
+          </a:p>
+        </p:txBody>
+      </p:sp>
+      <p:sp>
+        <p:nvSpPr>
+          <p:cNvPr id="21" name="Text 19"/>
+          <p:cNvSpPr txBox="1"/>
+          <p:nvPr/>
+        </p:nvSpPr>
+        <p:spPr>
+          <a:xfrm>
+            <a:off x="9221495" y="2359152"/>
+            <a:ext cx="2302688" cy="621792"/>
+          </a:xfrm>
+          <a:prstGeom prst="rect">
+            <a:avLst/>
+          </a:prstGeom>
+          <a:noFill/>
+          <a:ln/>
+        </p:spPr>
+        <p:txBody>
+          <a:bodyPr wrap="square" lIns="0" tIns="0" rIns="0" bIns="0" rtlCol="0" anchor="t"/>
+          <a:lstStyle/>
+          <a:p>
+            <a:pPr indent="0" marL="0">
+              <a:lnSpc>
+                <a:spcPct val="112000"/>
+              </a:lnSpc>
+              <a:buNone/>
+            </a:pPr>
+            <a:r>
+              <a:rPr lang="en-US" sz="1100" dirty="0">
+                <a:solidFill>
+                  <a:srgbClr val="5F6B72"/>
+                </a:solidFill>
+                <a:latin typeface="Calibri" pitchFamily="34" charset="0"/>
+                <a:ea typeface="Calibri" pitchFamily="34" charset="-122"/>
+                <a:cs typeface="Calibri" pitchFamily="34" charset="-120"/>
+              </a:rPr>
+              <a:t>Comparar el coste de producirlo con su precio de reposición</a:t>
+            </a:r>
+            <a:endParaRPr lang="en-US" sz="1100" dirty="0"/>
+          </a:p>
+        </p:txBody>
+      </p:sp>
+      <p:sp>
+        <p:nvSpPr>
+          <p:cNvPr id="22" name="Shape 20"/>
+          <p:cNvSpPr/>
+          <p:nvPr/>
+        </p:nvSpPr>
+        <p:spPr>
+          <a:xfrm>
+            <a:off x="11304727" y="1755648"/>
+            <a:ext cx="310896" cy="310896"/>
+          </a:xfrm>
+          <a:prstGeom prst="ellipse">
+            <a:avLst/>
+          </a:prstGeom>
+          <a:solidFill>
+            <a:srgbClr val="C8861E"/>
+          </a:solidFill>
+          <a:ln/>
+        </p:spPr>
+      </p:sp>
+      <p:sp>
+        <p:nvSpPr>
+          <p:cNvPr id="23" name="Text 21"/>
+          <p:cNvSpPr txBox="1"/>
+          <p:nvPr/>
+        </p:nvSpPr>
+        <p:spPr>
+          <a:xfrm>
+            <a:off x="11304727" y="1755648"/>
+            <a:ext cx="310896" cy="310896"/>
+          </a:xfrm>
+          <a:prstGeom prst="rect">
+            <a:avLst/>
+          </a:prstGeom>
+          <a:noFill/>
+          <a:ln/>
+        </p:spPr>
+        <p:txBody>
+          <a:bodyPr wrap="square" lIns="0" tIns="0" rIns="0" bIns="0" rtlCol="0" anchor="ctr"/>
+          <a:lstStyle/>
+          <a:p>
+            <a:pPr algn="ctr" indent="0" marL="0">
+              <a:buNone/>
+            </a:pPr>
+            <a:r>
+              <a:rPr lang="en-US" sz="1200" b="1" dirty="0">
+                <a:solidFill>
+                  <a:srgbClr val="10394A"/>
+                </a:solidFill>
+                <a:latin typeface="Calibri" pitchFamily="34" charset="0"/>
+                <a:ea typeface="Calibri" pitchFamily="34" charset="-122"/>
+                <a:cs typeface="Calibri" pitchFamily="34" charset="-120"/>
+              </a:rPr>
+              <a:t>2</a:t>
+            </a:r>
+            <a:endParaRPr lang="en-US" sz="1200" dirty="0"/>
+          </a:p>
+        </p:txBody>
+      </p:sp>
+      <p:sp>
+        <p:nvSpPr>
+          <p:cNvPr id="24" name="Shape 22"/>
+          <p:cNvSpPr/>
+          <p:nvPr/>
+        </p:nvSpPr>
+        <p:spPr>
+          <a:xfrm>
+            <a:off x="502920" y="3474720"/>
+            <a:ext cx="5364328" cy="1755648"/>
+          </a:xfrm>
+          <a:prstGeom prst="roundRect">
+            <a:avLst>
+              <a:gd name="adj" fmla="val 2604"/>
+            </a:avLst>
+          </a:prstGeom>
+          <a:solidFill>
+            <a:srgbClr val="FFFFFF"/>
+          </a:solidFill>
+          <a:ln w="12700">
+            <a:solidFill>
+              <a:srgbClr val="DDE3E6"/>
+            </a:solidFill>
+            <a:prstDash val="solid"/>
+          </a:ln>
+        </p:spPr>
+      </p:sp>
+      <p:sp>
+        <p:nvSpPr>
+          <p:cNvPr id="25" name="Shape 23"/>
+          <p:cNvSpPr/>
+          <p:nvPr/>
+        </p:nvSpPr>
+        <p:spPr>
+          <a:xfrm>
+            <a:off x="758952" y="3712464"/>
+            <a:ext cx="347472" cy="347472"/>
+          </a:xfrm>
+          <a:prstGeom prst="ellipse">
+            <a:avLst/>
+          </a:prstGeom>
+          <a:solidFill>
+            <a:srgbClr val="C8861E"/>
+          </a:solidFill>
+          <a:ln/>
+        </p:spPr>
+      </p:sp>
+      <p:sp>
+        <p:nvSpPr>
+          <p:cNvPr id="26" name="Text 24"/>
+          <p:cNvSpPr txBox="1"/>
+          <p:nvPr/>
+        </p:nvSpPr>
+        <p:spPr>
+          <a:xfrm>
+            <a:off x="758952" y="3712464"/>
+            <a:ext cx="347472" cy="347472"/>
+          </a:xfrm>
+          <a:prstGeom prst="rect">
+            <a:avLst/>
+          </a:prstGeom>
+          <a:noFill/>
+          <a:ln/>
+        </p:spPr>
+        <p:txBody>
+          <a:bodyPr wrap="square" lIns="0" tIns="0" rIns="0" bIns="0" rtlCol="0" anchor="ctr"/>
+          <a:lstStyle/>
+          <a:p>
+            <a:pPr algn="ctr" indent="0" marL="0">
+              <a:buNone/>
+            </a:pPr>
+            <a:r>
+              <a:rPr lang="en-US" sz="1300" b="1" dirty="0">
+                <a:solidFill>
+                  <a:srgbClr val="10394A"/>
+                </a:solidFill>
+                <a:latin typeface="Calibri" pitchFamily="34" charset="0"/>
+                <a:ea typeface="Calibri" pitchFamily="34" charset="-122"/>
+                <a:cs typeface="Calibri" pitchFamily="34" charset="-120"/>
+              </a:rPr>
+              <a:t>1</a:t>
+            </a:r>
+            <a:endParaRPr lang="en-US" sz="1300" dirty="0"/>
+          </a:p>
+        </p:txBody>
+      </p:sp>
+      <p:sp>
+        <p:nvSpPr>
+          <p:cNvPr id="27" name="Text 25"/>
+          <p:cNvSpPr txBox="1"/>
+          <p:nvPr/>
+        </p:nvSpPr>
+        <p:spPr>
+          <a:xfrm>
+            <a:off x="1216152" y="3675888"/>
+            <a:ext cx="4395064" cy="292608"/>
+          </a:xfrm>
+          <a:prstGeom prst="rect">
+            <a:avLst/>
+          </a:prstGeom>
+          <a:noFill/>
+          <a:ln/>
+        </p:spPr>
+        <p:txBody>
+          <a:bodyPr wrap="square" lIns="0" tIns="0" rIns="0" bIns="0" rtlCol="0" anchor="ctr"/>
+          <a:lstStyle/>
+          <a:p>
+            <a:pPr indent="0" marL="0">
+              <a:buNone/>
+            </a:pPr>
+            <a:r>
+              <a:rPr lang="en-US" sz="1550" b="1" dirty="0">
+                <a:solidFill>
+                  <a:srgbClr val="10394A"/>
                 </a:solidFill>
                 <a:latin typeface="Cambria" pitchFamily="34" charset="0"/>
                 <a:ea typeface="Cambria" pitchFamily="34" charset="-122"/>
                 <a:cs typeface="Cambria" pitchFamily="34" charset="-120"/>
               </a:rPr>
-              <a:t>1</a:t>
-            </a:r>
-            <a:endParaRPr lang="en-US" sz="1700" dirty="0"/>
-          </a:p>
-        </p:txBody>
-      </p:sp>
-      <p:sp>
-        <p:nvSpPr>
-          <p:cNvPr id="7" name="Text 4"/>
-          <p:cNvSpPr txBox="1"/>
-          <p:nvPr/>
-        </p:nvSpPr>
-        <p:spPr>
-          <a:xfrm>
-            <a:off x="7863840" y="1993392"/>
-            <a:ext cx="3840480" cy="320040"/>
-          </a:xfrm>
-          <a:prstGeom prst="rect">
-            <a:avLst/>
-          </a:prstGeom>
-          <a:noFill/>
-          <a:ln/>
-        </p:spPr>
-        <p:txBody>
-          <a:bodyPr wrap="square" lIns="0" tIns="0" rIns="0" bIns="0" rtlCol="0" anchor="ctr"/>
-          <a:lstStyle/>
-          <a:p>
-            <a:pPr indent="0" marL="0">
-              <a:buNone/>
-            </a:pPr>
-            <a:r>
-              <a:rPr lang="en-US" sz="1400" b="1" dirty="0">
+              <a:t>La batería alimenta al electrolizador</a:t>
+            </a:r>
+            <a:endParaRPr lang="en-US" sz="1550" dirty="0"/>
+          </a:p>
+        </p:txBody>
+      </p:sp>
+      <p:sp>
+        <p:nvSpPr>
+          <p:cNvPr id="28" name="Text 26"/>
+          <p:cNvSpPr txBox="1"/>
+          <p:nvPr/>
+        </p:nvSpPr>
+        <p:spPr>
+          <a:xfrm>
+            <a:off x="1216152" y="3986784"/>
+            <a:ext cx="4395064" cy="237744"/>
+          </a:xfrm>
+          <a:prstGeom prst="rect">
+            <a:avLst/>
+          </a:prstGeom>
+          <a:noFill/>
+          <a:ln/>
+        </p:spPr>
+        <p:txBody>
+          <a:bodyPr wrap="square" lIns="0" tIns="0" rIns="0" bIns="0" rtlCol="0" anchor="ctr"/>
+          <a:lstStyle/>
+          <a:p>
+            <a:pPr indent="0" marL="0">
+              <a:buNone/>
+            </a:pPr>
+            <a:r>
+              <a:rPr lang="en-US" sz="1000" b="1" spc="80" kern="0" dirty="0">
+                <a:solidFill>
+                  <a:srgbClr val="C8861E"/>
+                </a:solidFill>
+                <a:latin typeface="Calibri" pitchFamily="34" charset="0"/>
+                <a:ea typeface="Calibri" pitchFamily="34" charset="-122"/>
+                <a:cs typeface="Calibri" pitchFamily="34" charset="-120"/>
+              </a:rPr>
+              <a:t>sustituye al paso 3</a:t>
+            </a:r>
+            <a:endParaRPr lang="en-US" sz="1000" dirty="0"/>
+          </a:p>
+        </p:txBody>
+      </p:sp>
+      <p:sp>
+        <p:nvSpPr>
+          <p:cNvPr id="29" name="Text 27"/>
+          <p:cNvSpPr txBox="1"/>
+          <p:nvPr/>
+        </p:nvSpPr>
+        <p:spPr>
+          <a:xfrm>
+            <a:off x="795528" y="4315968"/>
+            <a:ext cx="4779112" cy="841248"/>
+          </a:xfrm>
+          <a:prstGeom prst="rect">
+            <a:avLst/>
+          </a:prstGeom>
+          <a:noFill/>
+          <a:ln/>
+        </p:spPr>
+        <p:txBody>
+          <a:bodyPr wrap="square" lIns="0" tIns="0" rIns="0" bIns="0" rtlCol="0" anchor="t"/>
+          <a:lstStyle/>
+          <a:p>
+            <a:pPr indent="0" marL="0">
+              <a:lnSpc>
+                <a:spcPct val="114000"/>
+              </a:lnSpc>
+              <a:buNone/>
+            </a:pPr>
+            <a:r>
+              <a:rPr lang="en-US" sz="1200" dirty="0">
+                <a:solidFill>
+                  <a:srgbClr val="1C1C1C"/>
+                </a:solidFill>
+                <a:latin typeface="Calibri" pitchFamily="34" charset="0"/>
+                <a:ea typeface="Calibri" pitchFamily="34" charset="-122"/>
+                <a:cs typeface="Calibri" pitchFamily="34" charset="-120"/>
+              </a:rPr>
+              <a:t>La carga que crea la decisión de producir hidrógeno se ofrece a la batería antes que a la red, mientras el estado de carga esté por encima del 60 %. Diez líneas, y sin usar ninguna previsión.</a:t>
+            </a:r>
+            <a:endParaRPr lang="en-US" sz="1200" dirty="0"/>
+          </a:p>
+        </p:txBody>
+      </p:sp>
+      <p:sp>
+        <p:nvSpPr>
+          <p:cNvPr id="30" name="Shape 28"/>
+          <p:cNvSpPr/>
+          <p:nvPr/>
+        </p:nvSpPr>
+        <p:spPr>
+          <a:xfrm>
+            <a:off x="6324448" y="3474720"/>
+            <a:ext cx="5364328" cy="1755648"/>
+          </a:xfrm>
+          <a:prstGeom prst="roundRect">
+            <a:avLst>
+              <a:gd name="adj" fmla="val 2604"/>
+            </a:avLst>
+          </a:prstGeom>
+          <a:solidFill>
+            <a:srgbClr val="FFFFFF"/>
+          </a:solidFill>
+          <a:ln w="12700">
+            <a:solidFill>
+              <a:srgbClr val="DDE3E6"/>
+            </a:solidFill>
+            <a:prstDash val="solid"/>
+          </a:ln>
+        </p:spPr>
+      </p:sp>
+      <p:sp>
+        <p:nvSpPr>
+          <p:cNvPr id="31" name="Shape 29"/>
+          <p:cNvSpPr/>
+          <p:nvPr/>
+        </p:nvSpPr>
+        <p:spPr>
+          <a:xfrm>
+            <a:off x="6580480" y="3712464"/>
+            <a:ext cx="347472" cy="347472"/>
+          </a:xfrm>
+          <a:prstGeom prst="ellipse">
+            <a:avLst/>
+          </a:prstGeom>
+          <a:solidFill>
+            <a:srgbClr val="C8861E"/>
+          </a:solidFill>
+          <a:ln/>
+        </p:spPr>
+      </p:sp>
+      <p:sp>
+        <p:nvSpPr>
+          <p:cNvPr id="32" name="Text 30"/>
+          <p:cNvSpPr txBox="1"/>
+          <p:nvPr/>
+        </p:nvSpPr>
+        <p:spPr>
+          <a:xfrm>
+            <a:off x="6580480" y="3712464"/>
+            <a:ext cx="347472" cy="347472"/>
+          </a:xfrm>
+          <a:prstGeom prst="rect">
+            <a:avLst/>
+          </a:prstGeom>
+          <a:noFill/>
+          <a:ln/>
+        </p:spPr>
+        <p:txBody>
+          <a:bodyPr wrap="square" lIns="0" tIns="0" rIns="0" bIns="0" rtlCol="0" anchor="ctr"/>
+          <a:lstStyle/>
+          <a:p>
+            <a:pPr algn="ctr" indent="0" marL="0">
+              <a:buNone/>
+            </a:pPr>
+            <a:r>
+              <a:rPr lang="en-US" sz="1300" b="1" dirty="0">
                 <a:solidFill>
                   <a:srgbClr val="10394A"/>
                 </a:solidFill>
@@ -6813,142 +7702,100 @@
                 <a:ea typeface="Calibri" pitchFamily="34" charset="-122"/>
                 <a:cs typeface="Calibri" pitchFamily="34" charset="-120"/>
               </a:rPr>
-              <a:t>La batería alimenta al electrolizador</a:t>
-            </a:r>
-            <a:endParaRPr lang="en-US" sz="1400" dirty="0"/>
-          </a:p>
-        </p:txBody>
-      </p:sp>
-      <p:sp>
-        <p:nvSpPr>
-          <p:cNvPr id="8" name="Text 5"/>
-          <p:cNvSpPr txBox="1"/>
-          <p:nvPr/>
-        </p:nvSpPr>
-        <p:spPr>
-          <a:xfrm>
-            <a:off x="7863840" y="2340864"/>
-            <a:ext cx="3840480" cy="1161288"/>
-          </a:xfrm>
-          <a:prstGeom prst="rect">
-            <a:avLst/>
-          </a:prstGeom>
-          <a:noFill/>
-          <a:ln/>
-        </p:spPr>
-        <p:txBody>
-          <a:bodyPr wrap="square" lIns="0" tIns="0" rIns="0" bIns="0" rtlCol="0" anchor="t"/>
-          <a:lstStyle/>
-          <a:p>
-            <a:pPr indent="0" marL="0">
-              <a:lnSpc>
-                <a:spcPct val="112000"/>
-              </a:lnSpc>
-              <a:buNone/>
-            </a:pPr>
-            <a:r>
-              <a:rPr lang="en-US" sz="1150" dirty="0">
-                <a:solidFill>
-                  <a:srgbClr val="5F6B72"/>
-                </a:solidFill>
-                <a:latin typeface="Calibri" pitchFamily="34" charset="0"/>
-                <a:ea typeface="Calibri" pitchFamily="34" charset="-122"/>
-                <a:cs typeface="Calibri" pitchFamily="34" charset="-120"/>
-              </a:rPr>
-              <a:t>Diez líneas: la carga que crea la decisión de producir H₂ se ofrece a la batería antes que a la red, con el SOC por encima del 60 %</a:t>
-            </a:r>
-            <a:endParaRPr lang="en-US" sz="1150" dirty="0"/>
-          </a:p>
-        </p:txBody>
-      </p:sp>
-      <p:sp>
-        <p:nvSpPr>
-          <p:cNvPr id="9" name="Text 6"/>
-          <p:cNvSpPr txBox="1"/>
-          <p:nvPr/>
-        </p:nvSpPr>
-        <p:spPr>
-          <a:xfrm>
-            <a:off x="7498080" y="3593592"/>
-            <a:ext cx="320040" cy="320040"/>
-          </a:xfrm>
-          <a:prstGeom prst="rect">
-            <a:avLst/>
-          </a:prstGeom>
-          <a:noFill/>
-          <a:ln/>
-        </p:spPr>
-        <p:txBody>
-          <a:bodyPr wrap="square" lIns="0" tIns="0" rIns="0" bIns="0" rtlCol="0" anchor="ctr"/>
-          <a:lstStyle/>
-          <a:p>
-            <a:pPr indent="0" marL="0">
-              <a:buNone/>
-            </a:pPr>
-            <a:r>
-              <a:rPr lang="en-US" sz="1700" b="1" dirty="0">
-                <a:solidFill>
-                  <a:srgbClr val="C8861E"/>
+              <a:t>2</a:t>
+            </a:r>
+            <a:endParaRPr lang="en-US" sz="1300" dirty="0"/>
+          </a:p>
+        </p:txBody>
+      </p:sp>
+      <p:sp>
+        <p:nvSpPr>
+          <p:cNvPr id="33" name="Text 31"/>
+          <p:cNvSpPr txBox="1"/>
+          <p:nvPr/>
+        </p:nvSpPr>
+        <p:spPr>
+          <a:xfrm>
+            <a:off x="7037680" y="3675888"/>
+            <a:ext cx="4395064" cy="292608"/>
+          </a:xfrm>
+          <a:prstGeom prst="rect">
+            <a:avLst/>
+          </a:prstGeom>
+          <a:noFill/>
+          <a:ln/>
+        </p:spPr>
+        <p:txBody>
+          <a:bodyPr wrap="square" lIns="0" tIns="0" rIns="0" bIns="0" rtlCol="0" anchor="ctr"/>
+          <a:lstStyle/>
+          <a:p>
+            <a:pPr indent="0" marL="0">
+              <a:buNone/>
+            </a:pPr>
+            <a:r>
+              <a:rPr lang="en-US" sz="1550" b="1" dirty="0">
+                <a:solidFill>
+                  <a:srgbClr val="10394A"/>
                 </a:solidFill>
                 <a:latin typeface="Cambria" pitchFamily="34" charset="0"/>
                 <a:ea typeface="Cambria" pitchFamily="34" charset="-122"/>
                 <a:cs typeface="Cambria" pitchFamily="34" charset="-120"/>
               </a:rPr>
-              <a:t>2</a:t>
-            </a:r>
-            <a:endParaRPr lang="en-US" sz="1700" dirty="0"/>
-          </a:p>
-        </p:txBody>
-      </p:sp>
-      <p:sp>
-        <p:nvSpPr>
-          <p:cNvPr id="10" name="Text 7"/>
-          <p:cNvSpPr txBox="1"/>
-          <p:nvPr/>
-        </p:nvSpPr>
-        <p:spPr>
-          <a:xfrm>
-            <a:off x="7863840" y="3593592"/>
-            <a:ext cx="3840480" cy="320040"/>
-          </a:xfrm>
-          <a:prstGeom prst="rect">
-            <a:avLst/>
-          </a:prstGeom>
-          <a:noFill/>
-          <a:ln/>
-        </p:spPr>
-        <p:txBody>
-          <a:bodyPr wrap="square" lIns="0" tIns="0" rIns="0" bIns="0" rtlCol="0" anchor="ctr"/>
-          <a:lstStyle/>
-          <a:p>
-            <a:pPr indent="0" marL="0">
-              <a:buNone/>
-            </a:pPr>
-            <a:r>
-              <a:rPr lang="en-US" sz="1400" b="1" dirty="0">
-                <a:solidFill>
-                  <a:srgbClr val="10394A"/>
-                </a:solidFill>
-                <a:latin typeface="Calibri" pitchFamily="34" charset="0"/>
-                <a:ea typeface="Calibri" pitchFamily="34" charset="-122"/>
-                <a:cs typeface="Calibri" pitchFamily="34" charset="-120"/>
-              </a:rPr>
               <a:t>Planificador de orden de mérito a 24 h</a:t>
             </a:r>
-            <a:endParaRPr lang="en-US" sz="1400" dirty="0"/>
-          </a:p>
-        </p:txBody>
-      </p:sp>
-      <p:sp>
-        <p:nvSpPr>
-          <p:cNvPr id="11" name="Text 8"/>
-          <p:cNvSpPr txBox="1"/>
-          <p:nvPr/>
-        </p:nvSpPr>
-        <p:spPr>
-          <a:xfrm>
-            <a:off x="7863840" y="3941064"/>
-            <a:ext cx="3840480" cy="1161288"/>
+            <a:endParaRPr lang="en-US" sz="1550" dirty="0"/>
+          </a:p>
+        </p:txBody>
+      </p:sp>
+      <p:sp>
+        <p:nvSpPr>
+          <p:cNvPr id="34" name="Text 32"/>
+          <p:cNvSpPr txBox="1"/>
+          <p:nvPr/>
+        </p:nvSpPr>
+        <p:spPr>
+          <a:xfrm>
+            <a:off x="7037680" y="3986784"/>
+            <a:ext cx="4395064" cy="237744"/>
+          </a:xfrm>
+          <a:prstGeom prst="rect">
+            <a:avLst/>
+          </a:prstGeom>
+          <a:noFill/>
+          <a:ln/>
+        </p:spPr>
+        <p:txBody>
+          <a:bodyPr wrap="square" lIns="0" tIns="0" rIns="0" bIns="0" rtlCol="0" anchor="ctr"/>
+          <a:lstStyle/>
+          <a:p>
+            <a:pPr indent="0" marL="0">
+              <a:buNone/>
+            </a:pPr>
+            <a:r>
+              <a:rPr lang="en-US" sz="1000" b="1" spc="80" kern="0" dirty="0">
+                <a:solidFill>
+                  <a:srgbClr val="C8861E"/>
+                </a:solidFill>
+                <a:latin typeface="Calibri" pitchFamily="34" charset="0"/>
+                <a:ea typeface="Calibri" pitchFamily="34" charset="-122"/>
+                <a:cs typeface="Calibri" pitchFamily="34" charset="-120"/>
+              </a:rPr>
+              <a:t>sustituye al paso 4</a:t>
+            </a:r>
+            <a:endParaRPr lang="en-US" sz="1000" dirty="0"/>
+          </a:p>
+        </p:txBody>
+      </p:sp>
+      <p:sp>
+        <p:nvSpPr>
+          <p:cNvPr id="35" name="Text 33"/>
+          <p:cNvSpPr txBox="1"/>
+          <p:nvPr/>
+        </p:nvSpPr>
+        <p:spPr>
+          <a:xfrm>
+            <a:off x="6617056" y="4315968"/>
+            <a:ext cx="4779112" cy="841248"/>
           </a:xfrm>
           <a:prstGeom prst="rect">
             <a:avLst/>
@@ -6962,34 +7809,34 @@
           <a:p>
             <a:pPr indent="0" marL="0">
               <a:lnSpc>
-                <a:spcPct val="112000"/>
+                <a:spcPct val="114000"/>
               </a:lnSpc>
               <a:buNone/>
             </a:pPr>
             <a:r>
-              <a:rPr lang="en-US" sz="1150" dirty="0">
-                <a:solidFill>
-                  <a:srgbClr val="5F6B72"/>
-                </a:solidFill>
-                <a:latin typeface="Calibri" pitchFamily="34" charset="0"/>
-                <a:ea typeface="Calibri" pitchFamily="34" charset="-122"/>
-                <a:cs typeface="Calibri" pitchFamily="34" charset="-120"/>
-              </a:rPr>
-              <a:t>Se estima el H₂ que falta y el excedente previsto; se produce si la hora actual está entre las n más baratas del horizonte</a:t>
-            </a:r>
-            <a:endParaRPr lang="en-US" sz="1150" dirty="0"/>
-          </a:p>
-        </p:txBody>
-      </p:sp>
-      <p:sp>
-        <p:nvSpPr>
-          <p:cNvPr id="12" name="Shape 9"/>
+              <a:rPr lang="en-US" sz="1200" dirty="0">
+                <a:solidFill>
+                  <a:srgbClr val="1C1C1C"/>
+                </a:solidFill>
+                <a:latin typeface="Calibri" pitchFamily="34" charset="0"/>
+                <a:ea typeface="Calibri" pitchFamily="34" charset="-122"/>
+                <a:cs typeface="Calibri" pitchFamily="34" charset="-120"/>
+              </a:rPr>
+              <a:t>Estima cuánto hidrógeno falta y cuánto excedente gratis viene; de ahí salen las horas de electrolizador que hay que comprar, y se producen en las más baratas del horizonte.</a:t>
+            </a:r>
+            <a:endParaRPr lang="en-US" sz="1200" dirty="0"/>
+          </a:p>
+        </p:txBody>
+      </p:sp>
+      <p:sp>
+        <p:nvSpPr>
+          <p:cNvPr id="36" name="Shape 34"/>
           <p:cNvSpPr/>
           <p:nvPr/>
         </p:nvSpPr>
         <p:spPr>
           <a:xfrm>
-            <a:off x="502920" y="5623560"/>
+            <a:off x="502920" y="5468112"/>
             <a:ext cx="11185855" cy="566928"/>
           </a:xfrm>
           <a:prstGeom prst="roundRect">
@@ -7005,13 +7852,13 @@
       </p:sp>
       <p:sp>
         <p:nvSpPr>
-          <p:cNvPr id="13" name="Text 10"/>
-          <p:cNvSpPr txBox="1"/>
-          <p:nvPr/>
-        </p:nvSpPr>
-        <p:spPr>
-          <a:xfrm>
-            <a:off x="777240" y="5641848"/>
+          <p:cNvPr id="37" name="Text 35"/>
+          <p:cNvSpPr txBox="1"/>
+          <p:nvPr/>
+        </p:nvSpPr>
+        <p:spPr>
+          <a:xfrm>
+            <a:off x="777240" y="5486400"/>
             <a:ext cx="10637215" cy="530352"/>
           </a:xfrm>
           <a:prstGeom prst="rect">
@@ -7039,7 +7886,7 @@
                 <a:ea typeface="Calibri" pitchFamily="34" charset="-122"/>
                 <a:cs typeface="Calibri" pitchFamily="34" charset="-120"/>
               </a:rPr>
-              <a:t>El planificador solo usa el ORDEN de los precios: es invariante a cualquier transformación monótona de la previsión.</a:t>
+              <a:t>El planificador solo usa el ORDEN de los precios: cualquier previsión que conserve ese orden toma exactamente las mismas decisiones.</a:t>
             </a:r>
             <a:endParaRPr lang="en-US" sz="1350" dirty="0"/>
           </a:p>
@@ -7047,7 +7894,7 @@
       </p:sp>
       <p:sp>
         <p:nvSpPr>
-          <p:cNvPr id="14" name="Text 11"/>
+          <p:cNvPr id="38" name="Text 36"/>
           <p:cNvSpPr txBox="1"/>
           <p:nvPr/>
         </p:nvSpPr>
@@ -16076,7 +16923,7 @@
                 <a:ea typeface="Calibri" pitchFamily="34" charset="-122"/>
                 <a:cs typeface="Calibri" pitchFamily="34" charset="-120"/>
               </a:rPr>
-              <a:t>Adam con descenso de tasa · parada temprana por pérdida de validación</a:t>
+              <a:t>Adam con descenso de tasa de aprendizaje · parada temprana por pérdida de validación</a:t>
             </a:r>
             <a:endParaRPr lang="en-US" sz="1250" dirty="0"/>
           </a:p>
@@ -16297,48 +17144,9 @@
           </a:prstGeom>
         </p:spPr>
       </p:pic>
-      <p:sp>
-        <p:nvSpPr>
-          <p:cNvPr id="5" name="Text 2"/>
-          <p:cNvSpPr txBox="1"/>
-          <p:nvPr/>
-        </p:nvSpPr>
-        <p:spPr>
-          <a:xfrm>
-            <a:off x="502920" y="4050792"/>
-            <a:ext cx="5364328" cy="274320"/>
-          </a:xfrm>
-          <a:prstGeom prst="rect">
-            <a:avLst/>
-          </a:prstGeom>
-          <a:noFill/>
-          <a:ln/>
-        </p:spPr>
-        <p:txBody>
-          <a:bodyPr wrap="square" lIns="0" tIns="0" rIns="0" bIns="0" rtlCol="0" anchor="ctr"/>
-          <a:lstStyle/>
-          <a:p>
-            <a:pPr algn="ctr" indent="0" marL="0">
-              <a:buNone/>
-            </a:pPr>
-            <a:r>
-              <a:rPr lang="en-US" sz="1050" i="1" dirty="0">
-                <a:solidFill>
-                  <a:srgbClr val="5F6B72"/>
-                </a:solidFill>
-                <a:latin typeface="Calibri" pitchFamily="34" charset="0"/>
-                <a:ea typeface="Calibri" pitchFamily="34" charset="-122"/>
-                <a:cs typeface="Calibri" pitchFamily="34" charset="-120"/>
-              </a:rPr>
-              <a:t>Red solar frente al valor real en los cuatro días de campaña</a:t>
-            </a:r>
-            <a:endParaRPr lang="en-US" sz="1050" dirty="0"/>
-          </a:p>
-        </p:txBody>
-      </p:sp>
       <p:pic>
         <p:nvPicPr>
-          <p:cNvPr id="6" name="Image 1" descr="img/lstm_precio_MAEPorHorizon.png">    </p:cNvPr>
+          <p:cNvPr id="5" name="Image 1" descr="img/lstm_precio_MAEPorHorizon.png">    </p:cNvPr>
           <p:cNvPicPr>
             <a:picLocks noChangeAspect="1"/>
           </p:cNvPicPr>
@@ -16362,13 +17170,52 @@
       </p:pic>
       <p:sp>
         <p:nvSpPr>
+          <p:cNvPr id="6" name="Text 2"/>
+          <p:cNvSpPr txBox="1"/>
+          <p:nvPr/>
+        </p:nvSpPr>
+        <p:spPr>
+          <a:xfrm>
+            <a:off x="502920" y="4096512"/>
+            <a:ext cx="5364328" cy="274320"/>
+          </a:xfrm>
+          <a:prstGeom prst="rect">
+            <a:avLst/>
+          </a:prstGeom>
+          <a:noFill/>
+          <a:ln/>
+        </p:spPr>
+        <p:txBody>
+          <a:bodyPr wrap="square" lIns="0" tIns="0" rIns="0" bIns="0" rtlCol="0" anchor="ctr"/>
+          <a:lstStyle/>
+          <a:p>
+            <a:pPr algn="ctr" indent="0" marL="0">
+              <a:buNone/>
+            </a:pPr>
+            <a:r>
+              <a:rPr lang="en-US" sz="1050" i="1" dirty="0">
+                <a:solidFill>
+                  <a:srgbClr val="5F6B72"/>
+                </a:solidFill>
+                <a:latin typeface="Calibri" pitchFamily="34" charset="0"/>
+                <a:ea typeface="Calibri" pitchFamily="34" charset="-122"/>
+                <a:cs typeface="Calibri" pitchFamily="34" charset="-120"/>
+              </a:rPr>
+              <a:t>Red solar frente al valor real en los cuatro días de campaña</a:t>
+            </a:r>
+            <a:endParaRPr lang="en-US" sz="1050" dirty="0"/>
+          </a:p>
+        </p:txBody>
+      </p:sp>
+      <p:sp>
+        <p:nvSpPr>
           <p:cNvPr id="7" name="Text 3"/>
           <p:cNvSpPr txBox="1"/>
           <p:nvPr/>
         </p:nvSpPr>
         <p:spPr>
           <a:xfrm>
-            <a:off x="6324448" y="4050792"/>
+            <a:off x="6324448" y="4096512"/>
             <a:ext cx="5364328" cy="274320"/>
           </a:xfrm>
           <a:prstGeom prst="rect">
@@ -16407,8 +17254,8 @@
         </p:nvSpPr>
         <p:spPr>
           <a:xfrm>
-            <a:off x="502920" y="4526280"/>
-            <a:ext cx="3515258" cy="566928"/>
+            <a:off x="502920" y="4553712"/>
+            <a:ext cx="5364328" cy="566928"/>
           </a:xfrm>
           <a:prstGeom prst="rect">
             <a:avLst/>
@@ -16446,8 +17293,8 @@
         </p:nvSpPr>
         <p:spPr>
           <a:xfrm>
-            <a:off x="502920" y="5074920"/>
-            <a:ext cx="3515258" cy="713232"/>
+            <a:off x="502920" y="5102352"/>
+            <a:ext cx="5364328" cy="713232"/>
           </a:xfrm>
           <a:prstGeom prst="rect">
             <a:avLst/>
@@ -16488,8 +17335,8 @@
         </p:nvSpPr>
         <p:spPr>
           <a:xfrm>
-            <a:off x="4338218" y="4526280"/>
-            <a:ext cx="3515258" cy="566928"/>
+            <a:off x="6324448" y="4553712"/>
+            <a:ext cx="5364328" cy="566928"/>
           </a:xfrm>
           <a:prstGeom prst="rect">
             <a:avLst/>
@@ -16527,8 +17374,8 @@
         </p:nvSpPr>
         <p:spPr>
           <a:xfrm>
-            <a:off x="4338218" y="5074920"/>
-            <a:ext cx="3515258" cy="713232"/>
+            <a:off x="6324448" y="5102352"/>
+            <a:ext cx="5364328" cy="713232"/>
           </a:xfrm>
           <a:prstGeom prst="rect">
             <a:avLst/>
@@ -16563,42 +17410,25 @@
       </p:sp>
       <p:sp>
         <p:nvSpPr>
-          <p:cNvPr id="12" name="Text 8"/>
-          <p:cNvSpPr txBox="1"/>
-          <p:nvPr/>
-        </p:nvSpPr>
-        <p:spPr>
-          <a:xfrm>
-            <a:off x="8173517" y="4526280"/>
-            <a:ext cx="3515258" cy="566928"/>
-          </a:xfrm>
-          <a:prstGeom prst="rect">
-            <a:avLst/>
-          </a:prstGeom>
-          <a:noFill/>
-          <a:ln/>
-        </p:spPr>
-        <p:txBody>
-          <a:bodyPr wrap="square" lIns="0" tIns="0" rIns="0" bIns="0" rtlCol="0" anchor="ctr"/>
-          <a:lstStyle/>
-          <a:p>
-            <a:pPr indent="0" marL="0">
-              <a:buNone/>
-            </a:pPr>
-            <a:r>
-              <a:rPr lang="en-US" sz="3000" b="1" dirty="0">
-                <a:solidFill>
-                  <a:srgbClr val="C8861E"/>
-                </a:solidFill>
-                <a:latin typeface="Cambria" pitchFamily="34" charset="0"/>
-                <a:ea typeface="Cambria" pitchFamily="34" charset="-122"/>
-                <a:cs typeface="Cambria" pitchFamily="34" charset="-120"/>
-              </a:rPr>
-              <a:t>+ 27,7 %</a:t>
-            </a:r>
-            <a:endParaRPr lang="en-US" sz="3000" dirty="0"/>
-          </a:p>
-        </p:txBody>
+          <p:cNvPr id="12" name="Shape 8"/>
+          <p:cNvSpPr/>
+          <p:nvPr/>
+        </p:nvSpPr>
+        <p:spPr>
+          <a:xfrm>
+            <a:off x="502920" y="5623560"/>
+            <a:ext cx="11185855" cy="566928"/>
+          </a:xfrm>
+          <a:prstGeom prst="roundRect">
+            <a:avLst>
+              <a:gd name="adj" fmla="val 9677"/>
+            </a:avLst>
+          </a:prstGeom>
+          <a:solidFill>
+            <a:srgbClr val="10394A"/>
+          </a:solidFill>
+          <a:ln/>
+        </p:spPr>
       </p:sp>
       <p:sp>
         <p:nvSpPr>
@@ -16608,37 +17438,37 @@
         </p:nvSpPr>
         <p:spPr>
           <a:xfrm>
-            <a:off x="8173517" y="5074920"/>
-            <a:ext cx="3515258" cy="713232"/>
-          </a:xfrm>
-          <a:prstGeom prst="rect">
-            <a:avLst/>
-          </a:prstGeom>
-          <a:noFill/>
-          <a:ln/>
-        </p:spPr>
-        <p:txBody>
-          <a:bodyPr wrap="square" lIns="0" tIns="0" rIns="0" bIns="0" rtlCol="0" anchor="t"/>
+            <a:off x="777240" y="5641848"/>
+            <a:ext cx="10637215" cy="530352"/>
+          </a:xfrm>
+          <a:prstGeom prst="rect">
+            <a:avLst/>
+          </a:prstGeom>
+          <a:noFill/>
+          <a:ln/>
+        </p:spPr>
+        <p:txBody>
+          <a:bodyPr wrap="square" lIns="0" tIns="0" rIns="0" bIns="0" rtlCol="0" anchor="ctr"/>
           <a:lstStyle/>
           <a:p>
             <a:pPr indent="0" marL="0">
               <a:lnSpc>
-                <a:spcPct val="110000"/>
+                <a:spcPct val="112000"/>
               </a:lnSpc>
               <a:buNone/>
             </a:pPr>
             <a:r>
-              <a:rPr lang="en-US" sz="1200" dirty="0">
-                <a:solidFill>
-                  <a:srgbClr val="5F6B72"/>
-                </a:solidFill>
-                <a:latin typeface="Calibri" pitchFamily="34" charset="0"/>
-                <a:ea typeface="Calibri" pitchFamily="34" charset="-122"/>
-                <a:cs typeface="Calibri" pitchFamily="34" charset="-120"/>
-              </a:rPr>
-              <a:t>de MAE adicional que costaba una realimentación del buffer en lazo cerrado, detectada y corregida: todas las cifras que siguen son posteriores</a:t>
-            </a:r>
-            <a:endParaRPr lang="en-US" sz="1200" dirty="0"/>
+              <a:rPr lang="en-US" sz="1350" dirty="0">
+                <a:solidFill>
+                  <a:srgbClr val="FFFFFF"/>
+                </a:solidFill>
+                <a:latin typeface="Calibri" pitchFamily="34" charset="0"/>
+                <a:ea typeface="Calibri" pitchFamily="34" charset="-122"/>
+                <a:cs typeface="Calibri" pitchFamily="34" charset="-120"/>
+              </a:rPr>
+              <a:t>Las líneas base no son rivales fáciles: en estas dos series el día de hoy se parece muchísimo al de ayer. La red solo puede ganarles donde algo cambia.</a:t>
+            </a:r>
+            <a:endParaRPr lang="en-US" sz="1350" dirty="0"/>
           </a:p>
         </p:txBody>
       </p:sp>
@@ -16928,7 +17758,7 @@
                 <a:ea typeface="Calibri" pitchFamily="34" charset="-122"/>
                 <a:cs typeface="Calibri" pitchFamily="34" charset="-120"/>
               </a:rPr>
-              <a:t>La predicción se acota a la curva de cielo claro (k_max = 1,00): el MAE diurno baja de 59,4 a 56,0 Wh/m²</a:t>
+              <a:t>La predicción se acota a la curva de cielo claro: el error medio diurno baja de 59,4 a 56,0 Wh/m²</a:t>
             </a:r>
             <a:endParaRPr lang="en-US" sz="1300" dirty="0"/>
           </a:p>
@@ -17309,7 +18139,7 @@
                 <a:ea typeface="Calibri" pitchFamily="34" charset="-122"/>
                 <a:cs typeface="Calibri" pitchFamily="34" charset="-120"/>
               </a:rPr>
-              <a:t>skill solar</a:t>
+              <a:t>mejor que la persistencia de cielo claro</a:t>
             </a:r>
             <a:endParaRPr lang="en-US" sz="1250" dirty="0"/>
           </a:p>
@@ -17387,7 +18217,7 @@
                 <a:ea typeface="Calibri" pitchFamily="34" charset="-122"/>
                 <a:cs typeface="Calibri" pitchFamily="34" charset="-120"/>
               </a:rPr>
-              <a:t>skill precio</a:t>
+              <a:t>mejor que la persistencia de 24 h</a:t>
             </a:r>
             <a:endParaRPr lang="en-US" sz="1250" dirty="0"/>
           </a:p>

</xml_diff>